<commit_message>
③②⑦a comparison labels near points + closer panel letters + concise titles
- ③ design_cmp_panel: every design name is now placed beside its own data point
  with greedy collision avoidance (vs the old all-on-the-right leader column);
  short leader only when a label must be displaced. Removes the long leaders that
  bled between subplots in the deck export (helps ②). Panels (c) of figs 16/18/5.9.
- ② build_ppt_figs: panel letters now sit just inside each panel's top-left corner
  (next to the title) instead of floating above; clip tightened accordingly.
- ② fix: remove_autoslides now drops the slide relationship (not just the id), so
  repeated runs no longer orphan slide parts and corrupt the deck (LibreOffice
  "source could not be loaded"). Decks re-export cleanly.
- ⑦a de-verbose supplement titles (drop AIGC verbosity, keep real subscripts),
  remove the baked "(b)" + duplicate titles in figs 5.9 / 18.

Co-Authored-By: Claude Opus 4.8 <noreply@anthropic.com>
</commit_message>
<xml_diff>
--- a/article/ppt/Chapter05_local.pptx
+++ b/article/ppt/Chapter05_local.pptx
@@ -6269,7 +6269,7 @@
         <p:spPr>
           <a:xfrm>
             <a:off x="228600" y="502920"/>
-            <a:ext cx="2810256" cy="2651772"/>
+            <a:ext cx="2810256" cy="2893637"/>
           </a:xfrm>
           <a:prstGeom prst="rect">
             <a:avLst/>
@@ -6284,8 +6284,8 @@
         </p:nvSpPr>
         <p:spPr>
           <a:xfrm>
-            <a:off x="274320" y="192024"/>
-            <a:ext cx="914400" cy="292608"/>
+            <a:off x="274320" y="521208"/>
+            <a:ext cx="548640" cy="274320"/>
           </a:xfrm>
           <a:prstGeom prst="rect">
             <a:avLst/>
@@ -6326,7 +6326,7 @@
         <p:spPr>
           <a:xfrm>
             <a:off x="3166872" y="502920"/>
-            <a:ext cx="2810256" cy="2348644"/>
+            <a:ext cx="2810256" cy="2355020"/>
           </a:xfrm>
           <a:prstGeom prst="rect">
             <a:avLst/>
@@ -6341,8 +6341,8 @@
         </p:nvSpPr>
         <p:spPr>
           <a:xfrm>
-            <a:off x="3212592" y="192024"/>
-            <a:ext cx="914400" cy="292608"/>
+            <a:off x="3212592" y="521208"/>
+            <a:ext cx="548640" cy="274320"/>
           </a:xfrm>
           <a:prstGeom prst="rect">
             <a:avLst/>
@@ -6383,7 +6383,7 @@
         <p:spPr>
           <a:xfrm>
             <a:off x="6105144" y="502920"/>
-            <a:ext cx="2810256" cy="2362426"/>
+            <a:ext cx="2810256" cy="2356099"/>
           </a:xfrm>
           <a:prstGeom prst="rect">
             <a:avLst/>
@@ -6398,8 +6398,8 @@
         </p:nvSpPr>
         <p:spPr>
           <a:xfrm>
-            <a:off x="6150864" y="192024"/>
-            <a:ext cx="914400" cy="292608"/>
+            <a:off x="6150864" y="521208"/>
+            <a:ext cx="548640" cy="274320"/>
           </a:xfrm>
           <a:prstGeom prst="rect">
             <a:avLst/>

</xml_diff>

<commit_message>
Update chapter decks: capability-table panels (figs 16/18/5.9c)
build_ppt_figs re-appended the analysis-figure slides with the new qualitative
capability-matrix (c) panels, replacing the retired scatter panels, so the decks
match the exported article/figs.

Co-Authored-By: Claude Opus 4.8 <noreply@anthropic.com>
</commit_message>
<xml_diff>
--- a/article/ppt/Chapter05_local.pptx
+++ b/article/ppt/Chapter05_local.pptx
@@ -6269,7 +6269,7 @@
         <p:spPr>
           <a:xfrm>
             <a:off x="228600" y="502920"/>
-            <a:ext cx="2810256" cy="2893637"/>
+            <a:ext cx="2810256" cy="2893454"/>
           </a:xfrm>
           <a:prstGeom prst="rect">
             <a:avLst/>
@@ -6326,7 +6326,7 @@
         <p:spPr>
           <a:xfrm>
             <a:off x="3166872" y="502920"/>
-            <a:ext cx="2810256" cy="2355020"/>
+            <a:ext cx="2810256" cy="2353716"/>
           </a:xfrm>
           <a:prstGeom prst="rect">
             <a:avLst/>
@@ -6383,7 +6383,7 @@
         <p:spPr>
           <a:xfrm>
             <a:off x="6105144" y="502920"/>
-            <a:ext cx="2810256" cy="2356099"/>
+            <a:ext cx="2810256" cy="2334805"/>
           </a:xfrm>
           <a:prstGeom prst="rect">
             <a:avLst/>

</xml_diff>

<commit_message>
Integrate quantitative comparison into panel (c) of figs 15/17/09 (deck-routed)
The qualitative capability matrix in panel (c) of the readout-SA (ch04_15), write-path
(ch04_17) and SAR (ch05_09) figures is replaced by the real same-flow quantitative
comparison. gen_supplement_figs.py now imports the design-survey plotters (one source
of truth, reading comparison_results.json) and renders them on ax[2]; panels routed
through the chapter decks and re-exported with deck-applied (a)(b)(c) letters. The
capability matrix relocates to the new circuit-design appendix as a markdown table.

Co-Authored-By: Claude Opus 4.8 <noreply@anthropic.com>
</commit_message>
<xml_diff>
--- a/article/ppt/Chapter05_local.pptx
+++ b/article/ppt/Chapter05_local.pptx
@@ -6269,7 +6269,7 @@
         <p:spPr>
           <a:xfrm>
             <a:off x="228600" y="502920"/>
-            <a:ext cx="2810256" cy="2893454"/>
+            <a:ext cx="2810256" cy="2906201"/>
           </a:xfrm>
           <a:prstGeom prst="rect">
             <a:avLst/>
@@ -6326,7 +6326,7 @@
         <p:spPr>
           <a:xfrm>
             <a:off x="3166872" y="502920"/>
-            <a:ext cx="2810256" cy="2353716"/>
+            <a:ext cx="2810256" cy="2364386"/>
           </a:xfrm>
           <a:prstGeom prst="rect">
             <a:avLst/>
@@ -6383,7 +6383,7 @@
         <p:spPr>
           <a:xfrm>
             <a:off x="6105144" y="502920"/>
-            <a:ext cx="2810256" cy="2334805"/>
+            <a:ext cx="2810256" cy="2191802"/>
           </a:xfrm>
           <a:prstGeom prst="rect">
             <a:avLst/>

</xml_diff>

<commit_message>
Refresh SAR comparison figures and text
</commit_message>
<xml_diff>
--- a/article/ppt/Chapter05_local.pptx
+++ b/article/ppt/Chapter05_local.pptx
@@ -6269,7 +6269,7 @@
         <p:spPr>
           <a:xfrm>
             <a:off x="228600" y="502920"/>
-            <a:ext cx="2810256" cy="2906201"/>
+            <a:ext cx="2810256" cy="2893454"/>
           </a:xfrm>
           <a:prstGeom prst="rect">
             <a:avLst/>
@@ -6326,7 +6326,7 @@
         <p:spPr>
           <a:xfrm>
             <a:off x="3166872" y="502920"/>
-            <a:ext cx="2810256" cy="2364386"/>
+            <a:ext cx="2810256" cy="2353716"/>
           </a:xfrm>
           <a:prstGeom prst="rect">
             <a:avLst/>
@@ -6383,7 +6383,7 @@
         <p:spPr>
           <a:xfrm>
             <a:off x="6105144" y="502920"/>
-            <a:ext cx="2810256" cy="2191802"/>
+            <a:ext cx="2810256" cy="2221130"/>
           </a:xfrm>
           <a:prstGeom prst="rect">
             <a:avLst/>

</xml_diff>

<commit_message>
Appendix decks + 总分式 captions + panel-letter overlay pipeline
Parallel-session work, reviewed and committed:
- New AppendixB/C/D decks; appendix figure captions reworked to
  summary-first (a)(b)... style; matching re-exported PNGs.
- build_ppt_figs.py: overlay mode for composed multi-panel plots
  (letters at detected axes corners); waveforms fig 4.19 via overlay.
- SAR switching generator now writes raw unlettered plots to figures/
  (sar_capdac_switching.*); AppendixD deck overlays letters and exports
  AppendixD_08.png (baked SVG removed).
- appendix_A: layer list folded to prose.
- gitignore: Appendix deck PDFs + per-slide PNG export dirs
  (regenerable).

Repairs added during review: restore missing ')' in ch5 rc_ipc DOI
link; update ch5 cross-ref 1.2.5节->1.2.4节 after ch1 renumbering; fix
one asymmetric parenthesis spacing in appendix_A.

Co-Authored-By: Claude Opus 4.8 <noreply@anthropic.com>
</commit_message>
<xml_diff>
--- a/article/ppt/Chapter05_local.pptx
+++ b/article/ppt/Chapter05_local.pptx
@@ -5,19 +5,19 @@
     <p:sldMasterId id="2147483648" r:id="rId1"/>
   </p:sldMasterIdLst>
   <p:notesMasterIdLst>
-    <p:notesMasterId r:id="rId11"/>
+    <p:notesMasterId r:id="rId4"/>
   </p:notesMasterIdLst>
   <p:sldIdLst>
     <p:sldId id="263" r:id="rId3"/>
-    <p:sldId id="265" r:id="rId4"/>
-    <p:sldId id="266" r:id="rId5"/>
-    <p:sldId id="267" r:id="rId6"/>
-    <p:sldId id="268" r:id="rId7"/>
-    <p:sldId id="269" r:id="rId8"/>
-    <p:sldId id="270" r:id="rId9"/>
-    <p:sldId id="272" r:id="rId15"/>
-    <p:sldId id="271" r:id="rId10"/>
-    <p:sldId id="273" r:id="rId16"/>
+    <p:sldId id="265" r:id="rId5"/>
+    <p:sldId id="266" r:id="rId6"/>
+    <p:sldId id="267" r:id="rId7"/>
+    <p:sldId id="268" r:id="rId8"/>
+    <p:sldId id="269" r:id="rId9"/>
+    <p:sldId id="270" r:id="rId10"/>
+    <p:sldId id="272" r:id="rId11"/>
+    <p:sldId id="271" r:id="rId12"/>
+    <p:sldId id="273" r:id="rId13"/>
   </p:sldIdLst>
   <p:sldSz cx="9144000" cy="6858000" type="screen4x3"/>
   <p:notesSz cx="6858000" cy="9144000"/>
@@ -467,7 +467,7 @@
 </file>
 
 <file path=ppt/notesSlides/notesSlide1.xml><?xml version="1.0" encoding="utf-8"?>
-<p:notes xmlns:a="http://schemas.openxmlformats.org/drawingml/2006/main" xmlns:p="http://schemas.openxmlformats.org/presentationml/2006/main" xmlns:r="http://schemas.openxmlformats.org/officeDocument/2006/relationships">
+<p:notes xmlns:a="http://schemas.openxmlformats.org/drawingml/2006/main" xmlns:r="http://schemas.openxmlformats.org/officeDocument/2006/relationships" xmlns:p="http://schemas.openxmlformats.org/presentationml/2006/main">
   <p:cSld>
     <p:spTree>
       <p:nvGrpSpPr>
@@ -502,7 +502,7 @@
             <a:spLocks noGrp="1"/>
           </p:cNvSpPr>
           <p:nvPr>
-            <p:ph type="body" idx="3" sz="quarter"/>
+            <p:ph type="body" sz="quarter" idx="3"/>
           </p:nvPr>
         </p:nvSpPr>
         <p:spPr/>
@@ -523,7 +523,7 @@
             <a:spLocks noGrp="1"/>
           </p:cNvSpPr>
           <p:nvPr>
-            <p:ph type="sldNum" idx="5" sz="quarter"/>
+            <p:ph type="sldNum" sz="quarter" idx="5"/>
           </p:nvPr>
         </p:nvSpPr>
         <p:spPr/>
@@ -537,7 +537,7 @@
 </file>
 
 <file path=ppt/notesSlides/notesSlide10.xml><?xml version="1.0" encoding="utf-8"?>
-<p:notes xmlns:a="http://schemas.openxmlformats.org/drawingml/2006/main" xmlns:p="http://schemas.openxmlformats.org/presentationml/2006/main" xmlns:r="http://schemas.openxmlformats.org/officeDocument/2006/relationships">
+<p:notes xmlns:a="http://schemas.openxmlformats.org/drawingml/2006/main" xmlns:r="http://schemas.openxmlformats.org/officeDocument/2006/relationships" xmlns:p="http://schemas.openxmlformats.org/presentationml/2006/main">
   <p:cSld>
     <p:spTree>
       <p:nvGrpSpPr>
@@ -572,7 +572,7 @@
             <a:spLocks noGrp="1"/>
           </p:cNvSpPr>
           <p:nvPr>
-            <p:ph type="body" idx="3" sz="quarter"/>
+            <p:ph type="body" sz="quarter" idx="3"/>
           </p:nvPr>
         </p:nvSpPr>
         <p:spPr/>
@@ -593,7 +593,7 @@
             <a:spLocks noGrp="1"/>
           </p:cNvSpPr>
           <p:nvPr>
-            <p:ph type="sldNum" idx="5" sz="quarter"/>
+            <p:ph type="sldNum" sz="quarter" idx="5"/>
           </p:nvPr>
         </p:nvSpPr>
         <p:spPr/>
@@ -607,7 +607,7 @@
 </file>
 
 <file path=ppt/notesSlides/notesSlide2.xml><?xml version="1.0" encoding="utf-8"?>
-<p:notes xmlns:a="http://schemas.openxmlformats.org/drawingml/2006/main" xmlns:p="http://schemas.openxmlformats.org/presentationml/2006/main" xmlns:r="http://schemas.openxmlformats.org/officeDocument/2006/relationships">
+<p:notes xmlns:a="http://schemas.openxmlformats.org/drawingml/2006/main" xmlns:r="http://schemas.openxmlformats.org/officeDocument/2006/relationships" xmlns:p="http://schemas.openxmlformats.org/presentationml/2006/main">
   <p:cSld>
     <p:spTree>
       <p:nvGrpSpPr>
@@ -642,7 +642,7 @@
             <a:spLocks noGrp="1"/>
           </p:cNvSpPr>
           <p:nvPr>
-            <p:ph type="body" idx="3" sz="quarter"/>
+            <p:ph type="body" sz="quarter" idx="3"/>
           </p:nvPr>
         </p:nvSpPr>
         <p:spPr/>
@@ -663,7 +663,7 @@
             <a:spLocks noGrp="1"/>
           </p:cNvSpPr>
           <p:nvPr>
-            <p:ph type="sldNum" idx="5" sz="quarter"/>
+            <p:ph type="sldNum" sz="quarter" idx="5"/>
           </p:nvPr>
         </p:nvSpPr>
         <p:spPr/>
@@ -677,7 +677,7 @@
 </file>
 
 <file path=ppt/notesSlides/notesSlide3.xml><?xml version="1.0" encoding="utf-8"?>
-<p:notes xmlns:a="http://schemas.openxmlformats.org/drawingml/2006/main" xmlns:p="http://schemas.openxmlformats.org/presentationml/2006/main" xmlns:r="http://schemas.openxmlformats.org/officeDocument/2006/relationships">
+<p:notes xmlns:a="http://schemas.openxmlformats.org/drawingml/2006/main" xmlns:r="http://schemas.openxmlformats.org/officeDocument/2006/relationships" xmlns:p="http://schemas.openxmlformats.org/presentationml/2006/main">
   <p:cSld>
     <p:spTree>
       <p:nvGrpSpPr>
@@ -712,7 +712,7 @@
             <a:spLocks noGrp="1"/>
           </p:cNvSpPr>
           <p:nvPr>
-            <p:ph type="body" idx="3" sz="quarter"/>
+            <p:ph type="body" sz="quarter" idx="3"/>
           </p:nvPr>
         </p:nvSpPr>
         <p:spPr/>
@@ -733,7 +733,7 @@
             <a:spLocks noGrp="1"/>
           </p:cNvSpPr>
           <p:nvPr>
-            <p:ph type="sldNum" idx="5" sz="quarter"/>
+            <p:ph type="sldNum" sz="quarter" idx="5"/>
           </p:nvPr>
         </p:nvSpPr>
         <p:spPr/>
@@ -747,7 +747,7 @@
 </file>
 
 <file path=ppt/notesSlides/notesSlide4.xml><?xml version="1.0" encoding="utf-8"?>
-<p:notes xmlns:a="http://schemas.openxmlformats.org/drawingml/2006/main" xmlns:p="http://schemas.openxmlformats.org/presentationml/2006/main" xmlns:r="http://schemas.openxmlformats.org/officeDocument/2006/relationships">
+<p:notes xmlns:a="http://schemas.openxmlformats.org/drawingml/2006/main" xmlns:r="http://schemas.openxmlformats.org/officeDocument/2006/relationships" xmlns:p="http://schemas.openxmlformats.org/presentationml/2006/main">
   <p:cSld>
     <p:spTree>
       <p:nvGrpSpPr>
@@ -782,7 +782,7 @@
             <a:spLocks noGrp="1"/>
           </p:cNvSpPr>
           <p:nvPr>
-            <p:ph type="body" idx="3" sz="quarter"/>
+            <p:ph type="body" sz="quarter" idx="3"/>
           </p:nvPr>
         </p:nvSpPr>
         <p:spPr/>
@@ -803,7 +803,7 @@
             <a:spLocks noGrp="1"/>
           </p:cNvSpPr>
           <p:nvPr>
-            <p:ph type="sldNum" idx="5" sz="quarter"/>
+            <p:ph type="sldNum" sz="quarter" idx="5"/>
           </p:nvPr>
         </p:nvSpPr>
         <p:spPr/>
@@ -817,7 +817,7 @@
 </file>
 
 <file path=ppt/notesSlides/notesSlide5.xml><?xml version="1.0" encoding="utf-8"?>
-<p:notes xmlns:a="http://schemas.openxmlformats.org/drawingml/2006/main" xmlns:p="http://schemas.openxmlformats.org/presentationml/2006/main" xmlns:r="http://schemas.openxmlformats.org/officeDocument/2006/relationships">
+<p:notes xmlns:a="http://schemas.openxmlformats.org/drawingml/2006/main" xmlns:r="http://schemas.openxmlformats.org/officeDocument/2006/relationships" xmlns:p="http://schemas.openxmlformats.org/presentationml/2006/main">
   <p:cSld>
     <p:spTree>
       <p:nvGrpSpPr>
@@ -852,7 +852,7 @@
             <a:spLocks noGrp="1"/>
           </p:cNvSpPr>
           <p:nvPr>
-            <p:ph type="body" idx="3" sz="quarter"/>
+            <p:ph type="body" sz="quarter" idx="3"/>
           </p:nvPr>
         </p:nvSpPr>
         <p:spPr/>
@@ -873,7 +873,7 @@
             <a:spLocks noGrp="1"/>
           </p:cNvSpPr>
           <p:nvPr>
-            <p:ph type="sldNum" idx="5" sz="quarter"/>
+            <p:ph type="sldNum" sz="quarter" idx="5"/>
           </p:nvPr>
         </p:nvSpPr>
         <p:spPr/>
@@ -887,7 +887,7 @@
 </file>
 
 <file path=ppt/notesSlides/notesSlide6.xml><?xml version="1.0" encoding="utf-8"?>
-<p:notes xmlns:a="http://schemas.openxmlformats.org/drawingml/2006/main" xmlns:p="http://schemas.openxmlformats.org/presentationml/2006/main" xmlns:r="http://schemas.openxmlformats.org/officeDocument/2006/relationships">
+<p:notes xmlns:a="http://schemas.openxmlformats.org/drawingml/2006/main" xmlns:r="http://schemas.openxmlformats.org/officeDocument/2006/relationships" xmlns:p="http://schemas.openxmlformats.org/presentationml/2006/main">
   <p:cSld>
     <p:spTree>
       <p:nvGrpSpPr>
@@ -922,7 +922,7 @@
             <a:spLocks noGrp="1"/>
           </p:cNvSpPr>
           <p:nvPr>
-            <p:ph type="body" idx="3" sz="quarter"/>
+            <p:ph type="body" sz="quarter" idx="3"/>
           </p:nvPr>
         </p:nvSpPr>
         <p:spPr/>
@@ -943,7 +943,7 @@
             <a:spLocks noGrp="1"/>
           </p:cNvSpPr>
           <p:nvPr>
-            <p:ph type="sldNum" idx="5" sz="quarter"/>
+            <p:ph type="sldNum" sz="quarter" idx="5"/>
           </p:nvPr>
         </p:nvSpPr>
         <p:spPr/>
@@ -957,7 +957,7 @@
 </file>
 
 <file path=ppt/notesSlides/notesSlide7.xml><?xml version="1.0" encoding="utf-8"?>
-<p:notes xmlns:a="http://schemas.openxmlformats.org/drawingml/2006/main" xmlns:p="http://schemas.openxmlformats.org/presentationml/2006/main" xmlns:r="http://schemas.openxmlformats.org/officeDocument/2006/relationships">
+<p:notes xmlns:a="http://schemas.openxmlformats.org/drawingml/2006/main" xmlns:r="http://schemas.openxmlformats.org/officeDocument/2006/relationships" xmlns:p="http://schemas.openxmlformats.org/presentationml/2006/main">
   <p:cSld>
     <p:spTree>
       <p:nvGrpSpPr>
@@ -992,7 +992,7 @@
             <a:spLocks noGrp="1"/>
           </p:cNvSpPr>
           <p:nvPr>
-            <p:ph type="body" idx="3" sz="quarter"/>
+            <p:ph type="body" sz="quarter" idx="3"/>
           </p:nvPr>
         </p:nvSpPr>
         <p:spPr/>
@@ -1013,7 +1013,7 @@
             <a:spLocks noGrp="1"/>
           </p:cNvSpPr>
           <p:nvPr>
-            <p:ph type="sldNum" idx="5" sz="quarter"/>
+            <p:ph type="sldNum" sz="quarter" idx="5"/>
           </p:nvPr>
         </p:nvSpPr>
         <p:spPr/>
@@ -1027,7 +1027,7 @@
 </file>
 
 <file path=ppt/notesSlides/notesSlide8.xml><?xml version="1.0" encoding="utf-8"?>
-<p:notes xmlns:a="http://schemas.openxmlformats.org/drawingml/2006/main" xmlns:p="http://schemas.openxmlformats.org/presentationml/2006/main" xmlns:r="http://schemas.openxmlformats.org/officeDocument/2006/relationships">
+<p:notes xmlns:a="http://schemas.openxmlformats.org/drawingml/2006/main" xmlns:r="http://schemas.openxmlformats.org/officeDocument/2006/relationships" xmlns:p="http://schemas.openxmlformats.org/presentationml/2006/main">
   <p:cSld>
     <p:spTree>
       <p:nvGrpSpPr>
@@ -1062,7 +1062,7 @@
             <a:spLocks noGrp="1"/>
           </p:cNvSpPr>
           <p:nvPr>
-            <p:ph type="body" idx="3" sz="quarter"/>
+            <p:ph type="body" sz="quarter" idx="3"/>
           </p:nvPr>
         </p:nvSpPr>
         <p:spPr/>
@@ -1071,7 +1071,7 @@
           <a:lstStyle/>
           <a:p>
             <a:r>
-              <a:t>FIG:09</a:t>
+              <a:t>FIG:08:VECTOR</a:t>
             </a:r>
           </a:p>
         </p:txBody>
@@ -1083,7 +1083,7 @@
             <a:spLocks noGrp="1"/>
           </p:cNvSpPr>
           <p:nvPr>
-            <p:ph type="sldNum" idx="5" sz="quarter"/>
+            <p:ph type="sldNum" sz="quarter" idx="5"/>
           </p:nvPr>
         </p:nvSpPr>
         <p:spPr/>
@@ -1097,7 +1097,7 @@
 </file>
 
 <file path=ppt/notesSlides/notesSlide9.xml><?xml version="1.0" encoding="utf-8"?>
-<p:notes xmlns:a="http://schemas.openxmlformats.org/drawingml/2006/main" xmlns:p="http://schemas.openxmlformats.org/presentationml/2006/main" xmlns:r="http://schemas.openxmlformats.org/officeDocument/2006/relationships">
+<p:notes xmlns:a="http://schemas.openxmlformats.org/drawingml/2006/main" xmlns:r="http://schemas.openxmlformats.org/officeDocument/2006/relationships" xmlns:p="http://schemas.openxmlformats.org/presentationml/2006/main">
   <p:cSld>
     <p:spTree>
       <p:nvGrpSpPr>
@@ -1132,7 +1132,7 @@
             <a:spLocks noGrp="1"/>
           </p:cNvSpPr>
           <p:nvPr>
-            <p:ph type="body" idx="3" sz="quarter"/>
+            <p:ph type="body" sz="quarter" idx="3"/>
           </p:nvPr>
         </p:nvSpPr>
         <p:spPr/>
@@ -1141,7 +1141,7 @@
           <a:lstStyle/>
           <a:p>
             <a:r>
-              <a:t>FIG:08:VECTOR</a:t>
+              <a:t>FIG:09</a:t>
             </a:r>
           </a:p>
         </p:txBody>
@@ -1153,7 +1153,7 @@
             <a:spLocks noGrp="1"/>
           </p:cNvSpPr>
           <p:nvPr>
-            <p:ph type="sldNum" idx="5" sz="quarter"/>
+            <p:ph type="sldNum" sz="quarter" idx="5"/>
           </p:nvPr>
         </p:nvSpPr>
         <p:spPr/>
@@ -3973,186 +3973,30 @@
         <p:nvPr/>
       </p:nvGrpSpPr>
       <p:grpSpPr/>
-      <p:grpSp>
-        <p:nvGrpSpPr>
-          <p:cNvPr id="10" name="组合 9"/>
-          <p:cNvGrpSpPr/>
+      <p:pic>
+        <p:nvPicPr>
+          <p:cNvPr id="11" name="图片 10" descr="05_reservoir_computing_principle"/>
+          <p:cNvPicPr>
+            <a:picLocks noChangeAspect="1"/>
+          </p:cNvPicPr>
           <p:nvPr/>
-        </p:nvGrpSpPr>
-        <p:grpSpPr>
-          <a:xfrm>
-            <a:off x="216535" y="329565"/>
-            <a:ext cx="8926830" cy="6313170"/>
-            <a:chOff x="341" y="519"/>
-            <a:chExt cx="14058" cy="9942"/>
-          </a:xfrm>
-        </p:grpSpPr>
-        <p:pic>
-          <p:nvPicPr>
-            <p:cNvPr id="3" name="图片 2" descr="ch05_principle"/>
-            <p:cNvPicPr>
-              <a:picLocks noChangeAspect="1"/>
-            </p:cNvPicPr>
-            <p:nvPr/>
-          </p:nvPicPr>
-          <p:blipFill>
-            <a:blip r:embed="rId1"/>
-            <a:stretch>
-              <a:fillRect/>
-            </a:stretch>
-          </p:blipFill>
-          <p:spPr>
-            <a:xfrm>
-              <a:off x="341" y="519"/>
-              <a:ext cx="14059" cy="9943"/>
-            </a:xfrm>
-            <a:prstGeom prst="rect">
-              <a:avLst/>
-            </a:prstGeom>
-          </p:spPr>
-        </p:pic>
-        <p:sp>
-          <p:nvSpPr>
-            <p:cNvPr id="2" name="矩形 1"/>
-            <p:cNvSpPr/>
-            <p:nvPr/>
-          </p:nvSpPr>
-          <p:spPr>
-            <a:xfrm>
-              <a:off x="1119" y="5620"/>
-              <a:ext cx="230" cy="285"/>
-            </a:xfrm>
-            <a:prstGeom prst="rect">
-              <a:avLst/>
-            </a:prstGeom>
-            <a:solidFill>
-              <a:schemeClr val="bg1"/>
-            </a:solidFill>
-            <a:ln>
-              <a:solidFill>
-                <a:schemeClr val="bg1"/>
-              </a:solidFill>
-            </a:ln>
-          </p:spPr>
-          <p:style>
-            <a:lnRef idx="2">
-              <a:schemeClr val="accent1">
-                <a:lumMod val="75000"/>
-              </a:schemeClr>
-            </a:lnRef>
-            <a:fillRef idx="1">
-              <a:schemeClr val="accent1"/>
-            </a:fillRef>
-            <a:effectRef idx="0">
-              <a:srgbClr val="FFFFFF"/>
-            </a:effectRef>
-            <a:fontRef idx="minor">
-              <a:schemeClr val="lt1"/>
-            </a:fontRef>
-          </p:style>
-          <p:txBody>
-            <a:bodyPr rtlCol="0" anchor="ctr"/>
-            <a:p>
-              <a:pPr algn="ctr"/>
-              <a:endParaRPr lang="zh-CN" altLang="en-US"/>
-            </a:p>
-          </p:txBody>
-        </p:sp>
-        <p:sp>
-          <p:nvSpPr>
-            <p:cNvPr id="4" name="矩形 3"/>
-            <p:cNvSpPr/>
-            <p:nvPr/>
-          </p:nvSpPr>
-          <p:spPr>
-            <a:xfrm>
-              <a:off x="6137" y="5620"/>
-              <a:ext cx="230" cy="285"/>
-            </a:xfrm>
-            <a:prstGeom prst="rect">
-              <a:avLst/>
-            </a:prstGeom>
-            <a:solidFill>
-              <a:schemeClr val="bg1"/>
-            </a:solidFill>
-            <a:ln>
-              <a:solidFill>
-                <a:schemeClr val="bg1"/>
-              </a:solidFill>
-            </a:ln>
-          </p:spPr>
-          <p:style>
-            <a:lnRef idx="2">
-              <a:schemeClr val="accent1">
-                <a:lumMod val="75000"/>
-              </a:schemeClr>
-            </a:lnRef>
-            <a:fillRef idx="1">
-              <a:schemeClr val="accent1"/>
-            </a:fillRef>
-            <a:effectRef idx="0">
-              <a:srgbClr val="FFFFFF"/>
-            </a:effectRef>
-            <a:fontRef idx="minor">
-              <a:schemeClr val="lt1"/>
-            </a:fontRef>
-          </p:style>
-          <p:txBody>
-            <a:bodyPr rtlCol="0" anchor="ctr"/>
-            <a:p>
-              <a:pPr algn="ctr"/>
-              <a:endParaRPr lang="zh-CN" altLang="en-US"/>
-            </a:p>
-          </p:txBody>
-        </p:sp>
-        <p:sp>
-          <p:nvSpPr>
-            <p:cNvPr id="5" name="矩形 4"/>
-            <p:cNvSpPr/>
-            <p:nvPr/>
-          </p:nvSpPr>
-          <p:spPr>
-            <a:xfrm>
-              <a:off x="11218" y="5620"/>
-              <a:ext cx="304" cy="285"/>
-            </a:xfrm>
-            <a:prstGeom prst="rect">
-              <a:avLst/>
-            </a:prstGeom>
-            <a:solidFill>
-              <a:schemeClr val="bg1"/>
-            </a:solidFill>
-            <a:ln>
-              <a:solidFill>
-                <a:schemeClr val="bg1"/>
-              </a:solidFill>
-            </a:ln>
-          </p:spPr>
-          <p:style>
-            <a:lnRef idx="2">
-              <a:schemeClr val="accent1">
-                <a:lumMod val="75000"/>
-              </a:schemeClr>
-            </a:lnRef>
-            <a:fillRef idx="1">
-              <a:schemeClr val="accent1"/>
-            </a:fillRef>
-            <a:effectRef idx="0">
-              <a:srgbClr val="FFFFFF"/>
-            </a:effectRef>
-            <a:fontRef idx="minor">
-              <a:schemeClr val="lt1"/>
-            </a:fontRef>
-          </p:style>
-          <p:txBody>
-            <a:bodyPr rtlCol="0" anchor="ctr"/>
-            <a:p>
-              <a:pPr algn="ctr"/>
-              <a:endParaRPr lang="zh-CN" altLang="en-US"/>
-            </a:p>
-          </p:txBody>
-        </p:sp>
-      </p:grpSp>
+        </p:nvPicPr>
+        <p:blipFill>
+          <a:blip r:embed="rId1"/>
+          <a:stretch>
+            <a:fillRect/>
+          </a:stretch>
+        </p:blipFill>
+        <p:spPr>
+          <a:xfrm>
+            <a:off x="176530" y="342900"/>
+            <a:ext cx="8967470" cy="6342380"/>
+          </a:xfrm>
+          <a:prstGeom prst="rect">
+            <a:avLst/>
+          </a:prstGeom>
+        </p:spPr>
+      </p:pic>
       <p:sp>
         <p:nvSpPr>
           <p:cNvPr id="6" name="文本框 5"/>
@@ -4161,7 +4005,7 @@
         </p:nvSpPr>
         <p:spPr>
           <a:xfrm>
-            <a:off x="3070701" y="3412966"/>
+            <a:off x="3070701" y="3430111"/>
             <a:ext cx="466249" cy="328613"/>
           </a:xfrm>
           <a:prstGeom prst="rect">
@@ -4170,23 +4014,15 @@
           <a:noFill/>
         </p:spPr>
         <p:txBody>
-          <a:bodyPr wrap="square" rtlCol="0">
+          <a:bodyPr wrap="none" rtlCol="0">
             <a:noAutofit/>
           </a:bodyPr>
           <a:p>
             <a:r>
-              <a:rPr lang="en-US" altLang="zh-CN" b="1">
-                <a:latin typeface="Arial" panose="020B0604020202020204" pitchFamily="34" charset="0"/>
-                <a:cs typeface="Arial" panose="020B0604020202020204" pitchFamily="34" charset="0"/>
+              <a:rPr b="1">
+                <a:latin typeface="Arial"/>
               </a:rPr>
-              <a:t>(</a:t>
-            </a:r>
-            <a:r>
-              <a:rPr lang="en-US" altLang="zh-CN" b="1">
-                <a:latin typeface="Arial" panose="020B0604020202020204" pitchFamily="34" charset="0"/>
-                <a:cs typeface="Arial" panose="020B0604020202020204" pitchFamily="34" charset="0"/>
-              </a:rPr>
-              <a:t>c)</a:t>
+              <a:t>(c)</a:t>
             </a:r>
             <a:endParaRPr lang="en-US" altLang="zh-CN" b="1">
               <a:latin typeface="Arial" panose="020B0604020202020204" pitchFamily="34" charset="0"/>
@@ -4203,7 +4039,7 @@
         </p:nvSpPr>
         <p:spPr>
           <a:xfrm>
-            <a:off x="6222841" y="3412331"/>
+            <a:off x="6222841" y="3429476"/>
             <a:ext cx="466249" cy="328613"/>
           </a:xfrm>
           <a:prstGeom prst="rect">
@@ -4212,23 +4048,15 @@
           <a:noFill/>
         </p:spPr>
         <p:txBody>
-          <a:bodyPr wrap="square" rtlCol="0">
+          <a:bodyPr wrap="none" rtlCol="0">
             <a:noAutofit/>
           </a:bodyPr>
           <a:p>
             <a:r>
-              <a:rPr lang="en-US" altLang="zh-CN" b="1">
-                <a:latin typeface="Arial" panose="020B0604020202020204" pitchFamily="34" charset="0"/>
-                <a:cs typeface="Arial" panose="020B0604020202020204" pitchFamily="34" charset="0"/>
+              <a:rPr b="1">
+                <a:latin typeface="Arial"/>
               </a:rPr>
-              <a:t>(</a:t>
-            </a:r>
-            <a:r>
-              <a:rPr lang="en-US" altLang="zh-CN" b="1">
-                <a:latin typeface="Arial" panose="020B0604020202020204" pitchFamily="34" charset="0"/>
-                <a:cs typeface="Arial" panose="020B0604020202020204" pitchFamily="34" charset="0"/>
-              </a:rPr>
-              <a:t>d)</a:t>
+              <a:t>(d)</a:t>
             </a:r>
             <a:endParaRPr lang="en-US" altLang="zh-CN" b="1">
               <a:latin typeface="Arial" panose="020B0604020202020204" pitchFamily="34" charset="0"/>
@@ -4245,7 +4073,7 @@
         </p:nvSpPr>
         <p:spPr>
           <a:xfrm>
-            <a:off x="-61754" y="3412966"/>
+            <a:off x="-90329" y="3430111"/>
             <a:ext cx="466249" cy="328613"/>
           </a:xfrm>
           <a:prstGeom prst="rect">
@@ -4254,14 +4082,13 @@
           <a:noFill/>
         </p:spPr>
         <p:txBody>
-          <a:bodyPr wrap="square" rtlCol="0">
+          <a:bodyPr wrap="none" rtlCol="0">
             <a:noAutofit/>
           </a:bodyPr>
           <a:p>
             <a:r>
-              <a:rPr lang="en-US" altLang="zh-CN" b="1">
-                <a:latin typeface="Arial" panose="020B0604020202020204" pitchFamily="34" charset="0"/>
-                <a:cs typeface="Arial" panose="020B0604020202020204" pitchFamily="34" charset="0"/>
+              <a:rPr b="1">
+                <a:latin typeface="Arial"/>
               </a:rPr>
               <a:t>(b)</a:t>
             </a:r>
@@ -4280,7 +4107,7 @@
         </p:nvSpPr>
         <p:spPr>
           <a:xfrm>
-            <a:off x="-61754" y="229711"/>
+            <a:off x="-90329" y="229711"/>
             <a:ext cx="466249" cy="328613"/>
           </a:xfrm>
           <a:prstGeom prst="rect">
@@ -4289,14 +4116,13 @@
           <a:noFill/>
         </p:spPr>
         <p:txBody>
-          <a:bodyPr wrap="square" rtlCol="0">
+          <a:bodyPr wrap="none" rtlCol="0">
             <a:noAutofit/>
           </a:bodyPr>
           <a:p>
             <a:r>
-              <a:rPr lang="en-US" altLang="zh-CN" b="1">
-                <a:latin typeface="Arial" panose="020B0604020202020204" pitchFamily="34" charset="0"/>
-                <a:cs typeface="Arial" panose="020B0604020202020204" pitchFamily="34" charset="0"/>
+              <a:rPr b="1">
+                <a:latin typeface="Arial"/>
               </a:rPr>
               <a:t>(a)</a:t>
             </a:r>
@@ -4316,7 +4142,7 @@
 </file>
 
 <file path=ppt/slides/slide10.xml><?xml version="1.0" encoding="utf-8"?>
-<p:sld xmlns:a="http://schemas.openxmlformats.org/drawingml/2006/main" xmlns:p="http://schemas.openxmlformats.org/presentationml/2006/main" xmlns:r="http://schemas.openxmlformats.org/officeDocument/2006/relationships">
+<p:sld xmlns:a="http://schemas.openxmlformats.org/drawingml/2006/main" xmlns:r="http://schemas.openxmlformats.org/officeDocument/2006/relationships" xmlns:p="http://schemas.openxmlformats.org/presentationml/2006/main">
   <p:cSld>
     <p:spTree>
       <p:nvGrpSpPr>
@@ -4378,15 +4204,16 @@
           <p:nvPr/>
         </p:nvPicPr>
         <p:blipFill>
-          <a:blip r:embed="rId2"/>
+          <a:blip r:embed="rId1"/>
+          <a:srcRect t="13409"/>
           <a:stretch>
             <a:fillRect/>
           </a:stretch>
         </p:blipFill>
         <p:spPr>
           <a:xfrm>
-            <a:off x="228600" y="502920"/>
-            <a:ext cx="8686800" cy="4252583"/>
+            <a:off x="228600" y="1073150"/>
+            <a:ext cx="8686800" cy="3682365"/>
           </a:xfrm>
           <a:prstGeom prst="rect">
             <a:avLst/>
@@ -4750,14 +4577,13 @@
           <a:noFill/>
         </p:spPr>
         <p:txBody>
-          <a:bodyPr wrap="square" rtlCol="0">
+          <a:bodyPr wrap="none" rtlCol="0">
             <a:noAutofit/>
           </a:bodyPr>
           <a:p>
             <a:r>
-              <a:rPr lang="en-US" altLang="zh-CN" sz="1200" b="1">
-                <a:latin typeface="Arial" panose="020B0604020202020204" pitchFamily="34" charset="0"/>
-                <a:cs typeface="Arial" panose="020B0604020202020204" pitchFamily="34" charset="0"/>
+              <a:rPr b="1" sz="1200">
+                <a:latin typeface="Arial"/>
               </a:rPr>
               <a:t>(a)</a:t>
             </a:r>
@@ -4785,23 +4611,15 @@
           <a:noFill/>
         </p:spPr>
         <p:txBody>
-          <a:bodyPr wrap="square" rtlCol="0">
+          <a:bodyPr wrap="none" rtlCol="0">
             <a:noAutofit/>
           </a:bodyPr>
           <a:p>
             <a:r>
-              <a:rPr lang="en-US" altLang="zh-CN" sz="1200" b="1">
-                <a:latin typeface="Arial" panose="020B0604020202020204" pitchFamily="34" charset="0"/>
-                <a:cs typeface="Arial" panose="020B0604020202020204" pitchFamily="34" charset="0"/>
+              <a:rPr b="1" sz="1200">
+                <a:latin typeface="Arial"/>
               </a:rPr>
-              <a:t>(</a:t>
-            </a:r>
-            <a:r>
-              <a:rPr lang="en-US" altLang="zh-CN" sz="1200" b="1">
-                <a:latin typeface="Arial" panose="020B0604020202020204" pitchFamily="34" charset="0"/>
-                <a:cs typeface="Arial" panose="020B0604020202020204" pitchFamily="34" charset="0"/>
-              </a:rPr>
-              <a:t>b)</a:t>
+              <a:t>(b)</a:t>
             </a:r>
             <a:endParaRPr lang="en-US" altLang="zh-CN" sz="1200" b="1">
               <a:latin typeface="Arial" panose="020B0604020202020204" pitchFamily="34" charset="0"/>
@@ -4827,23 +4645,15 @@
           <a:noFill/>
         </p:spPr>
         <p:txBody>
-          <a:bodyPr wrap="square" rtlCol="0">
+          <a:bodyPr wrap="none" rtlCol="0">
             <a:noAutofit/>
           </a:bodyPr>
           <a:p>
             <a:r>
-              <a:rPr lang="en-US" altLang="zh-CN" sz="1200" b="1">
-                <a:latin typeface="Arial" panose="020B0604020202020204" pitchFamily="34" charset="0"/>
-                <a:cs typeface="Arial" panose="020B0604020202020204" pitchFamily="34" charset="0"/>
+              <a:rPr b="1" sz="1200">
+                <a:latin typeface="Arial"/>
               </a:rPr>
-              <a:t>(</a:t>
-            </a:r>
-            <a:r>
-              <a:rPr lang="en-US" altLang="zh-CN" sz="1200" b="1">
-                <a:latin typeface="Arial" panose="020B0604020202020204" pitchFamily="34" charset="0"/>
-                <a:cs typeface="Arial" panose="020B0604020202020204" pitchFamily="34" charset="0"/>
-              </a:rPr>
-              <a:t>c)</a:t>
+              <a:t>(c)</a:t>
             </a:r>
             <a:endParaRPr lang="en-US" altLang="zh-CN" sz="1200" b="1">
               <a:latin typeface="Arial" panose="020B0604020202020204" pitchFamily="34" charset="0"/>
@@ -4869,23 +4679,15 @@
           <a:noFill/>
         </p:spPr>
         <p:txBody>
-          <a:bodyPr wrap="square" rtlCol="0">
+          <a:bodyPr wrap="none" rtlCol="0">
             <a:noAutofit/>
           </a:bodyPr>
           <a:p>
             <a:r>
-              <a:rPr lang="en-US" altLang="zh-CN" sz="1200" b="1">
-                <a:latin typeface="Arial" panose="020B0604020202020204" pitchFamily="34" charset="0"/>
-                <a:cs typeface="Arial" panose="020B0604020202020204" pitchFamily="34" charset="0"/>
+              <a:rPr b="1" sz="1200">
+                <a:latin typeface="Arial"/>
               </a:rPr>
-              <a:t>(</a:t>
-            </a:r>
-            <a:r>
-              <a:rPr lang="en-US" altLang="zh-CN" sz="1200" b="1">
-                <a:latin typeface="Arial" panose="020B0604020202020204" pitchFamily="34" charset="0"/>
-                <a:cs typeface="Arial" panose="020B0604020202020204" pitchFamily="34" charset="0"/>
-              </a:rPr>
-              <a:t>d)</a:t>
+              <a:t>(d)</a:t>
             </a:r>
             <a:endParaRPr lang="en-US" altLang="zh-CN" sz="1200" b="1">
               <a:latin typeface="Arial" panose="020B0604020202020204" pitchFamily="34" charset="0"/>
@@ -4911,23 +4713,15 @@
           <a:noFill/>
         </p:spPr>
         <p:txBody>
-          <a:bodyPr wrap="square" rtlCol="0">
+          <a:bodyPr wrap="none" rtlCol="0">
             <a:noAutofit/>
           </a:bodyPr>
           <a:p>
             <a:r>
-              <a:rPr lang="en-US" altLang="zh-CN" sz="1200" b="1">
-                <a:latin typeface="Arial" panose="020B0604020202020204" pitchFamily="34" charset="0"/>
-                <a:cs typeface="Arial" panose="020B0604020202020204" pitchFamily="34" charset="0"/>
+              <a:rPr b="1" sz="1200">
+                <a:latin typeface="Arial"/>
               </a:rPr>
-              <a:t>(</a:t>
-            </a:r>
-            <a:r>
-              <a:rPr lang="en-US" altLang="zh-CN" sz="1200" b="1">
-                <a:latin typeface="Arial" panose="020B0604020202020204" pitchFamily="34" charset="0"/>
-                <a:cs typeface="Arial" panose="020B0604020202020204" pitchFamily="34" charset="0"/>
-              </a:rPr>
-              <a:t>e)</a:t>
+              <a:t>(e)</a:t>
             </a:r>
             <a:endParaRPr lang="en-US" altLang="zh-CN" sz="1200" b="1">
               <a:latin typeface="Arial" panose="020B0604020202020204" pitchFamily="34" charset="0"/>
@@ -4953,23 +4747,15 @@
           <a:noFill/>
         </p:spPr>
         <p:txBody>
-          <a:bodyPr wrap="square" rtlCol="0">
+          <a:bodyPr wrap="none" rtlCol="0">
             <a:noAutofit/>
           </a:bodyPr>
           <a:p>
             <a:r>
-              <a:rPr lang="en-US" altLang="zh-CN" sz="1200" b="1">
-                <a:latin typeface="Arial" panose="020B0604020202020204" pitchFamily="34" charset="0"/>
-                <a:cs typeface="Arial" panose="020B0604020202020204" pitchFamily="34" charset="0"/>
+              <a:rPr b="1" sz="1200">
+                <a:latin typeface="Arial"/>
               </a:rPr>
-              <a:t>(</a:t>
-            </a:r>
-            <a:r>
-              <a:rPr lang="en-US" altLang="zh-CN" sz="1200" b="1">
-                <a:latin typeface="Arial" panose="020B0604020202020204" pitchFamily="34" charset="0"/>
-                <a:cs typeface="Arial" panose="020B0604020202020204" pitchFamily="34" charset="0"/>
-              </a:rPr>
-              <a:t>f)</a:t>
+              <a:t>(f)</a:t>
             </a:r>
             <a:endParaRPr lang="en-US" altLang="zh-CN" sz="1200" b="1">
               <a:latin typeface="Arial" panose="020B0604020202020204" pitchFamily="34" charset="0"/>
@@ -4996,234 +4782,31 @@
         <p:nvPr/>
       </p:nvGrpSpPr>
       <p:grpSpPr/>
-      <p:grpSp>
-        <p:nvGrpSpPr>
-          <p:cNvPr id="9" name="组合 8"/>
-          <p:cNvGrpSpPr/>
+      <p:pic>
+        <p:nvPicPr>
+          <p:cNvPr id="2" name="图片 1" descr="15_rc_device_optimization"/>
+          <p:cNvPicPr>
+            <a:picLocks noChangeAspect="1"/>
+          </p:cNvPicPr>
           <p:nvPr/>
-        </p:nvGrpSpPr>
-        <p:grpSpPr>
-          <a:xfrm>
-            <a:off x="0" y="625475"/>
-            <a:ext cx="9144000" cy="6078220"/>
-            <a:chOff x="0" y="985"/>
-            <a:chExt cx="14400" cy="9572"/>
-          </a:xfrm>
-        </p:grpSpPr>
-        <p:pic>
-          <p:nvPicPr>
-            <p:cNvPr id="4" name="图片 3"/>
-            <p:cNvPicPr>
-              <a:picLocks noChangeAspect="1"/>
-            </p:cNvPicPr>
-            <p:nvPr/>
-          </p:nvPicPr>
-          <p:blipFill>
-            <a:blip r:embed="rId1"/>
-            <a:srcRect t="7194"/>
-            <a:stretch>
-              <a:fillRect/>
-            </a:stretch>
-          </p:blipFill>
-          <p:spPr>
-            <a:xfrm>
-              <a:off x="0" y="985"/>
-              <a:ext cx="14400" cy="9572"/>
-            </a:xfrm>
-            <a:prstGeom prst="rect">
-              <a:avLst/>
-            </a:prstGeom>
-          </p:spPr>
-        </p:pic>
-        <p:sp>
-          <p:nvSpPr>
-            <p:cNvPr id="5" name="矩形 4"/>
-            <p:cNvSpPr/>
-            <p:nvPr/>
-          </p:nvSpPr>
-          <p:spPr>
-            <a:xfrm>
-              <a:off x="1557" y="1049"/>
-              <a:ext cx="232" cy="224"/>
-            </a:xfrm>
-            <a:prstGeom prst="rect">
-              <a:avLst/>
-            </a:prstGeom>
-            <a:solidFill>
-              <a:schemeClr val="bg1"/>
-            </a:solidFill>
-            <a:ln>
-              <a:solidFill>
-                <a:schemeClr val="bg1"/>
-              </a:solidFill>
-            </a:ln>
-          </p:spPr>
-          <p:style>
-            <a:lnRef idx="2">
-              <a:schemeClr val="accent1">
-                <a:lumMod val="75000"/>
-              </a:schemeClr>
-            </a:lnRef>
-            <a:fillRef idx="1">
-              <a:schemeClr val="accent1"/>
-            </a:fillRef>
-            <a:effectRef idx="0">
-              <a:srgbClr val="FFFFFF"/>
-            </a:effectRef>
-            <a:fontRef idx="minor">
-              <a:schemeClr val="lt1"/>
-            </a:fontRef>
-          </p:style>
-          <p:txBody>
-            <a:bodyPr rtlCol="0" anchor="ctr"/>
-            <a:p>
-              <a:pPr algn="ctr"/>
-              <a:endParaRPr lang="zh-CN" altLang="en-US"/>
-            </a:p>
-          </p:txBody>
-        </p:sp>
-        <p:sp>
-          <p:nvSpPr>
-            <p:cNvPr id="6" name="矩形 5"/>
-            <p:cNvSpPr/>
-            <p:nvPr/>
-          </p:nvSpPr>
-          <p:spPr>
-            <a:xfrm>
-              <a:off x="9424" y="1049"/>
-              <a:ext cx="232" cy="224"/>
-            </a:xfrm>
-            <a:prstGeom prst="rect">
-              <a:avLst/>
-            </a:prstGeom>
-            <a:solidFill>
-              <a:schemeClr val="bg1"/>
-            </a:solidFill>
-            <a:ln>
-              <a:solidFill>
-                <a:schemeClr val="bg1"/>
-              </a:solidFill>
-            </a:ln>
-          </p:spPr>
-          <p:style>
-            <a:lnRef idx="2">
-              <a:schemeClr val="accent1">
-                <a:lumMod val="75000"/>
-              </a:schemeClr>
-            </a:lnRef>
-            <a:fillRef idx="1">
-              <a:schemeClr val="accent1"/>
-            </a:fillRef>
-            <a:effectRef idx="0">
-              <a:srgbClr val="FFFFFF"/>
-            </a:effectRef>
-            <a:fontRef idx="minor">
-              <a:schemeClr val="lt1"/>
-            </a:fontRef>
-          </p:style>
-          <p:txBody>
-            <a:bodyPr rtlCol="0" anchor="ctr"/>
-            <a:p>
-              <a:pPr algn="ctr"/>
-              <a:endParaRPr lang="zh-CN" altLang="en-US"/>
-            </a:p>
-          </p:txBody>
-        </p:sp>
-        <p:sp>
-          <p:nvSpPr>
-            <p:cNvPr id="7" name="矩形 6"/>
-            <p:cNvSpPr/>
-            <p:nvPr/>
-          </p:nvSpPr>
-          <p:spPr>
-            <a:xfrm>
-              <a:off x="8289" y="5810"/>
-              <a:ext cx="232" cy="224"/>
-            </a:xfrm>
-            <a:prstGeom prst="rect">
-              <a:avLst/>
-            </a:prstGeom>
-            <a:solidFill>
-              <a:schemeClr val="bg1"/>
-            </a:solidFill>
-            <a:ln>
-              <a:solidFill>
-                <a:schemeClr val="bg1"/>
-              </a:solidFill>
-            </a:ln>
-          </p:spPr>
-          <p:style>
-            <a:lnRef idx="2">
-              <a:schemeClr val="accent1">
-                <a:lumMod val="75000"/>
-              </a:schemeClr>
-            </a:lnRef>
-            <a:fillRef idx="1">
-              <a:schemeClr val="accent1"/>
-            </a:fillRef>
-            <a:effectRef idx="0">
-              <a:srgbClr val="FFFFFF"/>
-            </a:effectRef>
-            <a:fontRef idx="minor">
-              <a:schemeClr val="lt1"/>
-            </a:fontRef>
-          </p:style>
-          <p:txBody>
-            <a:bodyPr rtlCol="0" anchor="ctr"/>
-            <a:p>
-              <a:pPr algn="ctr"/>
-              <a:endParaRPr lang="zh-CN" altLang="en-US"/>
-            </a:p>
-          </p:txBody>
-        </p:sp>
-        <p:sp>
-          <p:nvSpPr>
-            <p:cNvPr id="8" name="矩形 7"/>
-            <p:cNvSpPr/>
-            <p:nvPr/>
-          </p:nvSpPr>
-          <p:spPr>
-            <a:xfrm>
-              <a:off x="1539" y="5810"/>
-              <a:ext cx="232" cy="224"/>
-            </a:xfrm>
-            <a:prstGeom prst="rect">
-              <a:avLst/>
-            </a:prstGeom>
-            <a:solidFill>
-              <a:schemeClr val="bg1"/>
-            </a:solidFill>
-            <a:ln>
-              <a:solidFill>
-                <a:schemeClr val="bg1"/>
-              </a:solidFill>
-            </a:ln>
-          </p:spPr>
-          <p:style>
-            <a:lnRef idx="2">
-              <a:schemeClr val="accent1">
-                <a:lumMod val="75000"/>
-              </a:schemeClr>
-            </a:lnRef>
-            <a:fillRef idx="1">
-              <a:schemeClr val="accent1"/>
-            </a:fillRef>
-            <a:effectRef idx="0">
-              <a:srgbClr val="FFFFFF"/>
-            </a:effectRef>
-            <a:fontRef idx="minor">
-              <a:schemeClr val="lt1"/>
-            </a:fontRef>
-          </p:style>
-          <p:txBody>
-            <a:bodyPr rtlCol="0" anchor="ctr"/>
-            <a:p>
-              <a:pPr algn="ctr"/>
-              <a:endParaRPr lang="zh-CN" altLang="en-US"/>
-            </a:p>
-          </p:txBody>
-        </p:sp>
-      </p:grpSp>
+        </p:nvPicPr>
+        <p:blipFill>
+          <a:blip r:embed="rId1"/>
+          <a:srcRect t="5517"/>
+          <a:stretch>
+            <a:fillRect/>
+          </a:stretch>
+        </p:blipFill>
+        <p:spPr>
+          <a:xfrm>
+            <a:off x="0" y="515620"/>
+            <a:ext cx="9144000" cy="6188075"/>
+          </a:xfrm>
+          <a:prstGeom prst="rect">
+            <a:avLst/>
+          </a:prstGeom>
+        </p:spPr>
+      </p:pic>
       <p:sp>
         <p:nvSpPr>
           <p:cNvPr id="17" name="文本框 16"/>
@@ -5241,14 +4824,13 @@
           <a:noFill/>
         </p:spPr>
         <p:txBody>
-          <a:bodyPr wrap="square" rtlCol="0">
+          <a:bodyPr wrap="none" rtlCol="0">
             <a:noAutofit/>
           </a:bodyPr>
           <a:p>
             <a:r>
-              <a:rPr lang="en-US" altLang="zh-CN" sz="1600" b="1">
-                <a:latin typeface="Arial" panose="020B0604020202020204" pitchFamily="34" charset="0"/>
-                <a:cs typeface="Arial" panose="020B0604020202020204" pitchFamily="34" charset="0"/>
+              <a:rPr b="1" sz="1600">
+                <a:latin typeface="Arial"/>
               </a:rPr>
               <a:t>(a)</a:t>
             </a:r>
@@ -5276,14 +4858,13 @@
           <a:noFill/>
         </p:spPr>
         <p:txBody>
-          <a:bodyPr wrap="square" rtlCol="0">
+          <a:bodyPr wrap="none" rtlCol="0">
             <a:noAutofit/>
           </a:bodyPr>
           <a:p>
             <a:r>
-              <a:rPr lang="en-US" altLang="zh-CN" sz="1600" b="1">
-                <a:latin typeface="Arial" panose="020B0604020202020204" pitchFamily="34" charset="0"/>
-                <a:cs typeface="Arial" panose="020B0604020202020204" pitchFamily="34" charset="0"/>
+              <a:rPr b="1" sz="1600">
+                <a:latin typeface="Arial"/>
               </a:rPr>
               <a:t>(b)</a:t>
             </a:r>
@@ -5311,14 +4892,13 @@
           <a:noFill/>
         </p:spPr>
         <p:txBody>
-          <a:bodyPr wrap="square" rtlCol="0">
+          <a:bodyPr wrap="none" rtlCol="0">
             <a:noAutofit/>
           </a:bodyPr>
           <a:p>
             <a:r>
-              <a:rPr lang="en-US" altLang="zh-CN" sz="1600" b="1">
-                <a:latin typeface="Arial" panose="020B0604020202020204" pitchFamily="34" charset="0"/>
-                <a:cs typeface="Arial" panose="020B0604020202020204" pitchFamily="34" charset="0"/>
+              <a:rPr b="1" sz="1600">
+                <a:latin typeface="Arial"/>
               </a:rPr>
               <a:t>(c)</a:t>
             </a:r>
@@ -5346,14 +4926,13 @@
           <a:noFill/>
         </p:spPr>
         <p:txBody>
-          <a:bodyPr wrap="square" rtlCol="0">
+          <a:bodyPr wrap="none" rtlCol="0">
             <a:noAutofit/>
           </a:bodyPr>
           <a:p>
             <a:r>
-              <a:rPr lang="en-US" altLang="zh-CN" sz="1600" b="1">
-                <a:latin typeface="Arial" panose="020B0604020202020204" pitchFamily="34" charset="0"/>
-                <a:cs typeface="Arial" panose="020B0604020202020204" pitchFamily="34" charset="0"/>
+              <a:rPr b="1" sz="1600">
+                <a:latin typeface="Arial"/>
               </a:rPr>
               <a:t>(d)</a:t>
             </a:r>
@@ -5627,14 +5206,13 @@
           <a:noFill/>
         </p:spPr>
         <p:txBody>
-          <a:bodyPr wrap="square" rtlCol="0">
+          <a:bodyPr wrap="none" rtlCol="0">
             <a:noAutofit/>
           </a:bodyPr>
           <a:p>
             <a:r>
-              <a:rPr lang="en-US" altLang="zh-CN" sz="1600" b="1">
-                <a:latin typeface="Arial" panose="020B0604020202020204" pitchFamily="34" charset="0"/>
-                <a:cs typeface="Arial" panose="020B0604020202020204" pitchFamily="34" charset="0"/>
+              <a:rPr b="1" sz="1600">
+                <a:latin typeface="Arial"/>
               </a:rPr>
               <a:t>(a)</a:t>
             </a:r>
@@ -5662,14 +5240,13 @@
           <a:noFill/>
         </p:spPr>
         <p:txBody>
-          <a:bodyPr wrap="square" rtlCol="0">
+          <a:bodyPr wrap="none" rtlCol="0">
             <a:noAutofit/>
           </a:bodyPr>
           <a:p>
             <a:r>
-              <a:rPr lang="en-US" altLang="zh-CN" sz="1600" b="1">
-                <a:latin typeface="Arial" panose="020B0604020202020204" pitchFamily="34" charset="0"/>
-                <a:cs typeface="Arial" panose="020B0604020202020204" pitchFamily="34" charset="0"/>
+              <a:rPr b="1" sz="1600">
+                <a:latin typeface="Arial"/>
               </a:rPr>
               <a:t>(b)</a:t>
             </a:r>
@@ -5697,14 +5274,13 @@
           <a:noFill/>
         </p:spPr>
         <p:txBody>
-          <a:bodyPr wrap="square" rtlCol="0">
+          <a:bodyPr wrap="none" rtlCol="0">
             <a:noAutofit/>
           </a:bodyPr>
           <a:p>
             <a:r>
-              <a:rPr lang="en-US" altLang="zh-CN" sz="1600" b="1">
-                <a:latin typeface="Arial" panose="020B0604020202020204" pitchFamily="34" charset="0"/>
-                <a:cs typeface="Arial" panose="020B0604020202020204" pitchFamily="34" charset="0"/>
+              <a:rPr b="1" sz="1600">
+                <a:latin typeface="Arial"/>
               </a:rPr>
               <a:t>(c)</a:t>
             </a:r>
@@ -5732,14 +5308,13 @@
           <a:noFill/>
         </p:spPr>
         <p:txBody>
-          <a:bodyPr wrap="square" rtlCol="0">
+          <a:bodyPr wrap="none" rtlCol="0">
             <a:noAutofit/>
           </a:bodyPr>
           <a:p>
             <a:r>
-              <a:rPr lang="en-US" altLang="zh-CN" sz="1600" b="1">
-                <a:latin typeface="Arial" panose="020B0604020202020204" pitchFamily="34" charset="0"/>
-                <a:cs typeface="Arial" panose="020B0604020202020204" pitchFamily="34" charset="0"/>
+              <a:rPr b="1" sz="1600">
+                <a:latin typeface="Arial"/>
               </a:rPr>
               <a:t>(d)</a:t>
             </a:r>
@@ -5768,234 +5343,31 @@
         <p:nvPr/>
       </p:nvGrpSpPr>
       <p:grpSpPr/>
-      <p:grpSp>
-        <p:nvGrpSpPr>
-          <p:cNvPr id="9" name="组合 8"/>
-          <p:cNvGrpSpPr/>
+      <p:pic>
+        <p:nvPicPr>
+          <p:cNvPr id="2" name="图片 1" descr="17_rc_robustness"/>
+          <p:cNvPicPr>
+            <a:picLocks noChangeAspect="1"/>
+          </p:cNvPicPr>
           <p:nvPr/>
-        </p:nvGrpSpPr>
-        <p:grpSpPr>
-          <a:xfrm>
-            <a:off x="0" y="654685"/>
-            <a:ext cx="9144000" cy="6040120"/>
-            <a:chOff x="0" y="1031"/>
-            <a:chExt cx="14400" cy="9512"/>
-          </a:xfrm>
-        </p:grpSpPr>
-        <p:pic>
-          <p:nvPicPr>
-            <p:cNvPr id="4" name="图片 3"/>
-            <p:cNvPicPr>
-              <a:picLocks noChangeAspect="1"/>
-            </p:cNvPicPr>
-            <p:nvPr/>
-          </p:nvPicPr>
-          <p:blipFill>
-            <a:blip r:embed="rId1"/>
-            <a:srcRect t="7542"/>
-            <a:stretch>
-              <a:fillRect/>
-            </a:stretch>
-          </p:blipFill>
-          <p:spPr>
-            <a:xfrm>
-              <a:off x="0" y="1031"/>
-              <a:ext cx="14400" cy="9513"/>
-            </a:xfrm>
-            <a:prstGeom prst="rect">
-              <a:avLst/>
-            </a:prstGeom>
-          </p:spPr>
-        </p:pic>
-        <p:sp>
-          <p:nvSpPr>
-            <p:cNvPr id="5" name="矩形 4"/>
-            <p:cNvSpPr/>
-            <p:nvPr/>
-          </p:nvSpPr>
-          <p:spPr>
-            <a:xfrm>
-              <a:off x="1544" y="1049"/>
-              <a:ext cx="232" cy="224"/>
-            </a:xfrm>
-            <a:prstGeom prst="rect">
-              <a:avLst/>
-            </a:prstGeom>
-            <a:solidFill>
-              <a:schemeClr val="bg1"/>
-            </a:solidFill>
-            <a:ln>
-              <a:solidFill>
-                <a:schemeClr val="bg1"/>
-              </a:solidFill>
-            </a:ln>
-          </p:spPr>
-          <p:style>
-            <a:lnRef idx="2">
-              <a:schemeClr val="accent1">
-                <a:lumMod val="75000"/>
-              </a:schemeClr>
-            </a:lnRef>
-            <a:fillRef idx="1">
-              <a:schemeClr val="accent1"/>
-            </a:fillRef>
-            <a:effectRef idx="0">
-              <a:srgbClr val="FFFFFF"/>
-            </a:effectRef>
-            <a:fontRef idx="minor">
-              <a:schemeClr val="lt1"/>
-            </a:fontRef>
-          </p:style>
-          <p:txBody>
-            <a:bodyPr rtlCol="0" anchor="ctr"/>
-            <a:p>
-              <a:pPr algn="ctr"/>
-              <a:endParaRPr lang="zh-CN" altLang="en-US"/>
-            </a:p>
-          </p:txBody>
-        </p:sp>
-        <p:sp>
-          <p:nvSpPr>
-            <p:cNvPr id="6" name="矩形 5"/>
-            <p:cNvSpPr/>
-            <p:nvPr/>
-          </p:nvSpPr>
-          <p:spPr>
-            <a:xfrm>
-              <a:off x="8960" y="1049"/>
-              <a:ext cx="232" cy="224"/>
-            </a:xfrm>
-            <a:prstGeom prst="rect">
-              <a:avLst/>
-            </a:prstGeom>
-            <a:solidFill>
-              <a:schemeClr val="bg1"/>
-            </a:solidFill>
-            <a:ln>
-              <a:solidFill>
-                <a:schemeClr val="bg1"/>
-              </a:solidFill>
-            </a:ln>
-          </p:spPr>
-          <p:style>
-            <a:lnRef idx="2">
-              <a:schemeClr val="accent1">
-                <a:lumMod val="75000"/>
-              </a:schemeClr>
-            </a:lnRef>
-            <a:fillRef idx="1">
-              <a:schemeClr val="accent1"/>
-            </a:fillRef>
-            <a:effectRef idx="0">
-              <a:srgbClr val="FFFFFF"/>
-            </a:effectRef>
-            <a:fontRef idx="minor">
-              <a:schemeClr val="lt1"/>
-            </a:fontRef>
-          </p:style>
-          <p:txBody>
-            <a:bodyPr rtlCol="0" anchor="ctr"/>
-            <a:p>
-              <a:pPr algn="ctr"/>
-              <a:endParaRPr lang="zh-CN" altLang="en-US"/>
-            </a:p>
-          </p:txBody>
-        </p:sp>
-        <p:sp>
-          <p:nvSpPr>
-            <p:cNvPr id="7" name="矩形 6"/>
-            <p:cNvSpPr/>
-            <p:nvPr/>
-          </p:nvSpPr>
-          <p:spPr>
-            <a:xfrm>
-              <a:off x="1835" y="5820"/>
-              <a:ext cx="232" cy="224"/>
-            </a:xfrm>
-            <a:prstGeom prst="rect">
-              <a:avLst/>
-            </a:prstGeom>
-            <a:solidFill>
-              <a:schemeClr val="bg1"/>
-            </a:solidFill>
-            <a:ln>
-              <a:solidFill>
-                <a:schemeClr val="bg1"/>
-              </a:solidFill>
-            </a:ln>
-          </p:spPr>
-          <p:style>
-            <a:lnRef idx="2">
-              <a:schemeClr val="accent1">
-                <a:lumMod val="75000"/>
-              </a:schemeClr>
-            </a:lnRef>
-            <a:fillRef idx="1">
-              <a:schemeClr val="accent1"/>
-            </a:fillRef>
-            <a:effectRef idx="0">
-              <a:srgbClr val="FFFFFF"/>
-            </a:effectRef>
-            <a:fontRef idx="minor">
-              <a:schemeClr val="lt1"/>
-            </a:fontRef>
-          </p:style>
-          <p:txBody>
-            <a:bodyPr rtlCol="0" anchor="ctr"/>
-            <a:p>
-              <a:pPr algn="ctr"/>
-              <a:endParaRPr lang="zh-CN" altLang="en-US"/>
-            </a:p>
-          </p:txBody>
-        </p:sp>
-        <p:sp>
-          <p:nvSpPr>
-            <p:cNvPr id="8" name="矩形 7"/>
-            <p:cNvSpPr/>
-            <p:nvPr/>
-          </p:nvSpPr>
-          <p:spPr>
-            <a:xfrm>
-              <a:off x="9516" y="5820"/>
-              <a:ext cx="232" cy="224"/>
-            </a:xfrm>
-            <a:prstGeom prst="rect">
-              <a:avLst/>
-            </a:prstGeom>
-            <a:solidFill>
-              <a:schemeClr val="bg1"/>
-            </a:solidFill>
-            <a:ln>
-              <a:solidFill>
-                <a:schemeClr val="bg1"/>
-              </a:solidFill>
-            </a:ln>
-          </p:spPr>
-          <p:style>
-            <a:lnRef idx="2">
-              <a:schemeClr val="accent1">
-                <a:lumMod val="75000"/>
-              </a:schemeClr>
-            </a:lnRef>
-            <a:fillRef idx="1">
-              <a:schemeClr val="accent1"/>
-            </a:fillRef>
-            <a:effectRef idx="0">
-              <a:srgbClr val="FFFFFF"/>
-            </a:effectRef>
-            <a:fontRef idx="minor">
-              <a:schemeClr val="lt1"/>
-            </a:fontRef>
-          </p:style>
-          <p:txBody>
-            <a:bodyPr rtlCol="0" anchor="ctr"/>
-            <a:p>
-              <a:pPr algn="ctr"/>
-              <a:endParaRPr lang="zh-CN" altLang="en-US"/>
-            </a:p>
-          </p:txBody>
-        </p:sp>
-      </p:grpSp>
+        </p:nvPicPr>
+        <p:blipFill>
+          <a:blip r:embed="rId1"/>
+          <a:srcRect t="7328"/>
+          <a:stretch>
+            <a:fillRect/>
+          </a:stretch>
+        </p:blipFill>
+        <p:spPr>
+          <a:xfrm>
+            <a:off x="0" y="640715"/>
+            <a:ext cx="9144000" cy="6054725"/>
+          </a:xfrm>
+          <a:prstGeom prst="rect">
+            <a:avLst/>
+          </a:prstGeom>
+        </p:spPr>
+      </p:pic>
       <p:sp>
         <p:nvSpPr>
           <p:cNvPr id="17" name="文本框 16"/>
@@ -6013,14 +5385,13 @@
           <a:noFill/>
         </p:spPr>
         <p:txBody>
-          <a:bodyPr wrap="square" rtlCol="0">
+          <a:bodyPr wrap="none" rtlCol="0">
             <a:noAutofit/>
           </a:bodyPr>
           <a:p>
             <a:r>
-              <a:rPr lang="en-US" altLang="zh-CN" sz="1600" b="1">
-                <a:latin typeface="Arial" panose="020B0604020202020204" pitchFamily="34" charset="0"/>
-                <a:cs typeface="Arial" panose="020B0604020202020204" pitchFamily="34" charset="0"/>
+              <a:rPr b="1" sz="1600">
+                <a:latin typeface="Arial"/>
               </a:rPr>
               <a:t>(a)</a:t>
             </a:r>
@@ -6048,14 +5419,13 @@
           <a:noFill/>
         </p:spPr>
         <p:txBody>
-          <a:bodyPr wrap="square" rtlCol="0">
+          <a:bodyPr wrap="none" rtlCol="0">
             <a:noAutofit/>
           </a:bodyPr>
           <a:p>
             <a:r>
-              <a:rPr lang="en-US" altLang="zh-CN" sz="1600" b="1">
-                <a:latin typeface="Arial" panose="020B0604020202020204" pitchFamily="34" charset="0"/>
-                <a:cs typeface="Arial" panose="020B0604020202020204" pitchFamily="34" charset="0"/>
+              <a:rPr b="1" sz="1600">
+                <a:latin typeface="Arial"/>
               </a:rPr>
               <a:t>(b)</a:t>
             </a:r>
@@ -6083,14 +5453,13 @@
           <a:noFill/>
         </p:spPr>
         <p:txBody>
-          <a:bodyPr wrap="square" rtlCol="0">
+          <a:bodyPr wrap="none" rtlCol="0">
             <a:noAutofit/>
           </a:bodyPr>
           <a:p>
             <a:r>
-              <a:rPr lang="en-US" altLang="zh-CN" sz="1600" b="1">
-                <a:latin typeface="Arial" panose="020B0604020202020204" pitchFamily="34" charset="0"/>
-                <a:cs typeface="Arial" panose="020B0604020202020204" pitchFamily="34" charset="0"/>
+              <a:rPr b="1" sz="1600">
+                <a:latin typeface="Arial"/>
               </a:rPr>
               <a:t>(c)</a:t>
             </a:r>
@@ -6118,14 +5487,13 @@
           <a:noFill/>
         </p:spPr>
         <p:txBody>
-          <a:bodyPr wrap="square" rtlCol="0">
+          <a:bodyPr wrap="none" rtlCol="0">
             <a:noAutofit/>
           </a:bodyPr>
           <a:p>
             <a:r>
-              <a:rPr lang="en-US" altLang="zh-CN" sz="1600" b="1">
-                <a:latin typeface="Arial" panose="020B0604020202020204" pitchFamily="34" charset="0"/>
-                <a:cs typeface="Arial" panose="020B0604020202020204" pitchFamily="34" charset="0"/>
+              <a:rPr b="1" sz="1600">
+                <a:latin typeface="Arial"/>
               </a:rPr>
               <a:t>(d)</a:t>
             </a:r>
@@ -6162,10 +5530,10 @@
         </p:nvGrpSpPr>
         <p:grpSpPr>
           <a:xfrm>
-            <a:off x="0" y="467995"/>
-            <a:ext cx="9144000" cy="6051550"/>
+            <a:off x="0" y="191770"/>
+            <a:ext cx="9144000" cy="6525895"/>
             <a:chOff x="0" y="1007"/>
-            <a:chExt cx="14400" cy="9530"/>
+            <a:chExt cx="14400" cy="10277"/>
           </a:xfrm>
         </p:grpSpPr>
         <p:pic>
@@ -6193,100 +5561,6 @@
             </a:prstGeom>
           </p:spPr>
         </p:pic>
-        <p:sp>
-          <p:nvSpPr>
-            <p:cNvPr id="5" name="矩形 4"/>
-            <p:cNvSpPr/>
-            <p:nvPr/>
-          </p:nvSpPr>
-          <p:spPr>
-            <a:xfrm>
-              <a:off x="2156" y="1010"/>
-              <a:ext cx="232" cy="224"/>
-            </a:xfrm>
-            <a:prstGeom prst="rect">
-              <a:avLst/>
-            </a:prstGeom>
-            <a:solidFill>
-              <a:schemeClr val="bg1"/>
-            </a:solidFill>
-            <a:ln>
-              <a:solidFill>
-                <a:schemeClr val="bg1"/>
-              </a:solidFill>
-            </a:ln>
-          </p:spPr>
-          <p:style>
-            <a:lnRef idx="2">
-              <a:schemeClr val="accent1">
-                <a:lumMod val="75000"/>
-              </a:schemeClr>
-            </a:lnRef>
-            <a:fillRef idx="1">
-              <a:schemeClr val="accent1"/>
-            </a:fillRef>
-            <a:effectRef idx="0">
-              <a:srgbClr val="FFFFFF"/>
-            </a:effectRef>
-            <a:fontRef idx="minor">
-              <a:schemeClr val="lt1"/>
-            </a:fontRef>
-          </p:style>
-          <p:txBody>
-            <a:bodyPr rtlCol="0" anchor="ctr"/>
-            <a:p>
-              <a:pPr algn="ctr"/>
-              <a:endParaRPr lang="zh-CN" altLang="en-US"/>
-            </a:p>
-          </p:txBody>
-        </p:sp>
-        <p:sp>
-          <p:nvSpPr>
-            <p:cNvPr id="6" name="矩形 5"/>
-            <p:cNvSpPr/>
-            <p:nvPr/>
-          </p:nvSpPr>
-          <p:spPr>
-            <a:xfrm>
-              <a:off x="9912" y="1010"/>
-              <a:ext cx="232" cy="224"/>
-            </a:xfrm>
-            <a:prstGeom prst="rect">
-              <a:avLst/>
-            </a:prstGeom>
-            <a:solidFill>
-              <a:schemeClr val="bg1"/>
-            </a:solidFill>
-            <a:ln>
-              <a:solidFill>
-                <a:schemeClr val="bg1"/>
-              </a:solidFill>
-            </a:ln>
-          </p:spPr>
-          <p:style>
-            <a:lnRef idx="2">
-              <a:schemeClr val="accent1">
-                <a:lumMod val="75000"/>
-              </a:schemeClr>
-            </a:lnRef>
-            <a:fillRef idx="1">
-              <a:schemeClr val="accent1"/>
-            </a:fillRef>
-            <a:effectRef idx="0">
-              <a:srgbClr val="FFFFFF"/>
-            </a:effectRef>
-            <a:fontRef idx="minor">
-              <a:schemeClr val="lt1"/>
-            </a:fontRef>
-          </p:style>
-          <p:txBody>
-            <a:bodyPr rtlCol="0" anchor="ctr"/>
-            <a:p>
-              <a:pPr algn="ctr"/>
-              <a:endParaRPr lang="zh-CN" altLang="en-US"/>
-            </a:p>
-          </p:txBody>
-        </p:sp>
         <p:sp>
           <p:nvSpPr>
             <p:cNvPr id="7" name="矩形 6"/>
@@ -6390,7 +5664,7 @@
         </p:nvSpPr>
         <p:spPr>
           <a:xfrm>
-            <a:off x="-9684" y="326866"/>
+            <a:off x="-9684" y="79216"/>
             <a:ext cx="466249" cy="328613"/>
           </a:xfrm>
           <a:prstGeom prst="rect">
@@ -6399,14 +5673,13 @@
           <a:noFill/>
         </p:spPr>
         <p:txBody>
-          <a:bodyPr wrap="square" rtlCol="0">
+          <a:bodyPr wrap="none" rtlCol="0">
             <a:noAutofit/>
           </a:bodyPr>
           <a:p>
             <a:r>
-              <a:rPr lang="en-US" altLang="zh-CN" sz="1600" b="1">
-                <a:latin typeface="Arial" panose="020B0604020202020204" pitchFamily="34" charset="0"/>
-                <a:cs typeface="Arial" panose="020B0604020202020204" pitchFamily="34" charset="0"/>
+              <a:rPr b="1" sz="1600">
+                <a:latin typeface="Arial"/>
               </a:rPr>
               <a:t>(a)</a:t>
             </a:r>
@@ -6425,7 +5698,7 @@
         </p:nvSpPr>
         <p:spPr>
           <a:xfrm>
-            <a:off x="4631055" y="326866"/>
+            <a:off x="4631055" y="79216"/>
             <a:ext cx="466249" cy="328613"/>
           </a:xfrm>
           <a:prstGeom prst="rect">
@@ -6434,14 +5707,13 @@
           <a:noFill/>
         </p:spPr>
         <p:txBody>
-          <a:bodyPr wrap="square" rtlCol="0">
+          <a:bodyPr wrap="none" rtlCol="0">
             <a:noAutofit/>
           </a:bodyPr>
           <a:p>
             <a:r>
-              <a:rPr lang="en-US" altLang="zh-CN" sz="1600" b="1">
-                <a:latin typeface="Arial" panose="020B0604020202020204" pitchFamily="34" charset="0"/>
-                <a:cs typeface="Arial" panose="020B0604020202020204" pitchFamily="34" charset="0"/>
+              <a:rPr b="1" sz="1600">
+                <a:latin typeface="Arial"/>
               </a:rPr>
               <a:t>(b)</a:t>
             </a:r>
@@ -6460,7 +5732,7 @@
         </p:nvSpPr>
         <p:spPr>
           <a:xfrm>
-            <a:off x="-9684" y="3353911"/>
+            <a:off x="-9684" y="3306286"/>
             <a:ext cx="466249" cy="328613"/>
           </a:xfrm>
           <a:prstGeom prst="rect">
@@ -6469,14 +5741,13 @@
           <a:noFill/>
         </p:spPr>
         <p:txBody>
-          <a:bodyPr wrap="square" rtlCol="0">
+          <a:bodyPr wrap="none" rtlCol="0">
             <a:noAutofit/>
           </a:bodyPr>
           <a:p>
             <a:r>
-              <a:rPr lang="en-US" altLang="zh-CN" sz="1600" b="1">
-                <a:latin typeface="Arial" panose="020B0604020202020204" pitchFamily="34" charset="0"/>
-                <a:cs typeface="Arial" panose="020B0604020202020204" pitchFamily="34" charset="0"/>
+              <a:rPr b="1" sz="1600">
+                <a:latin typeface="Arial"/>
               </a:rPr>
               <a:t>(c)</a:t>
             </a:r>
@@ -6495,7 +5766,7 @@
         </p:nvSpPr>
         <p:spPr>
           <a:xfrm>
-            <a:off x="4631055" y="3353911"/>
+            <a:off x="4631055" y="3306286"/>
             <a:ext cx="466249" cy="328613"/>
           </a:xfrm>
           <a:prstGeom prst="rect">
@@ -6504,14 +5775,13 @@
           <a:noFill/>
         </p:spPr>
         <p:txBody>
-          <a:bodyPr wrap="square" rtlCol="0">
+          <a:bodyPr wrap="none" rtlCol="0">
             <a:noAutofit/>
           </a:bodyPr>
           <a:p>
             <a:r>
-              <a:rPr lang="en-US" altLang="zh-CN" sz="1600" b="1">
-                <a:latin typeface="Arial" panose="020B0604020202020204" pitchFamily="34" charset="0"/>
-                <a:cs typeface="Arial" panose="020B0604020202020204" pitchFamily="34" charset="0"/>
+              <a:rPr b="1" sz="1600">
+                <a:latin typeface="Arial"/>
               </a:rPr>
               <a:t>(d)</a:t>
             </a:r>
@@ -6540,234 +5810,31 @@
         <p:nvPr/>
       </p:nvGrpSpPr>
       <p:grpSpPr/>
-      <p:grpSp>
-        <p:nvGrpSpPr>
-          <p:cNvPr id="9" name="组合 8"/>
-          <p:cNvGrpSpPr/>
+      <p:pic>
+        <p:nvPicPr>
+          <p:cNvPr id="2" name="图片 1" descr="16_rc_hardware_ppa"/>
+          <p:cNvPicPr>
+            <a:picLocks noChangeAspect="1"/>
+          </p:cNvPicPr>
           <p:nvPr/>
-        </p:nvGrpSpPr>
-        <p:grpSpPr>
+        </p:nvPicPr>
+        <p:blipFill>
+          <a:blip r:embed="rId1"/>
+          <a:srcRect t="7553"/>
+          <a:stretch>
+            <a:fillRect/>
+          </a:stretch>
+        </p:blipFill>
+        <p:spPr>
           <a:xfrm>
             <a:off x="0" y="659765"/>
             <a:ext cx="9144000" cy="6031230"/>
-            <a:chOff x="0" y="1039"/>
-            <a:chExt cx="14400" cy="9498"/>
-          </a:xfrm>
-        </p:grpSpPr>
-        <p:pic>
-          <p:nvPicPr>
-            <p:cNvPr id="4" name="图片 3"/>
-            <p:cNvPicPr>
-              <a:picLocks noChangeAspect="1"/>
-            </p:cNvPicPr>
-            <p:nvPr/>
-          </p:nvPicPr>
-          <p:blipFill>
-            <a:blip r:embed="rId1"/>
-            <a:srcRect t="7553"/>
-            <a:stretch>
-              <a:fillRect/>
-            </a:stretch>
-          </p:blipFill>
-          <p:spPr>
-            <a:xfrm>
-              <a:off x="0" y="1039"/>
-              <a:ext cx="14400" cy="9498"/>
-            </a:xfrm>
-            <a:prstGeom prst="rect">
-              <a:avLst/>
-            </a:prstGeom>
-          </p:spPr>
-        </p:pic>
-        <p:sp>
-          <p:nvSpPr>
-            <p:cNvPr id="5" name="矩形 4"/>
-            <p:cNvSpPr/>
-            <p:nvPr/>
-          </p:nvSpPr>
-          <p:spPr>
-            <a:xfrm>
-              <a:off x="1732" y="1039"/>
-              <a:ext cx="232" cy="224"/>
-            </a:xfrm>
-            <a:prstGeom prst="rect">
-              <a:avLst/>
-            </a:prstGeom>
-            <a:solidFill>
-              <a:schemeClr val="bg1"/>
-            </a:solidFill>
-            <a:ln>
-              <a:solidFill>
-                <a:schemeClr val="bg1"/>
-              </a:solidFill>
-            </a:ln>
-          </p:spPr>
-          <p:style>
-            <a:lnRef idx="2">
-              <a:schemeClr val="accent1">
-                <a:lumMod val="75000"/>
-              </a:schemeClr>
-            </a:lnRef>
-            <a:fillRef idx="1">
-              <a:schemeClr val="accent1"/>
-            </a:fillRef>
-            <a:effectRef idx="0">
-              <a:srgbClr val="FFFFFF"/>
-            </a:effectRef>
-            <a:fontRef idx="minor">
-              <a:schemeClr val="lt1"/>
-            </a:fontRef>
-          </p:style>
-          <p:txBody>
-            <a:bodyPr rtlCol="0" anchor="ctr"/>
-            <a:p>
-              <a:pPr algn="ctr"/>
-              <a:endParaRPr lang="zh-CN" altLang="en-US"/>
-            </a:p>
-          </p:txBody>
-        </p:sp>
-        <p:sp>
-          <p:nvSpPr>
-            <p:cNvPr id="6" name="矩形 5"/>
-            <p:cNvSpPr/>
-            <p:nvPr/>
-          </p:nvSpPr>
-          <p:spPr>
-            <a:xfrm>
-              <a:off x="9064" y="1039"/>
-              <a:ext cx="232" cy="224"/>
-            </a:xfrm>
-            <a:prstGeom prst="rect">
-              <a:avLst/>
-            </a:prstGeom>
-            <a:solidFill>
-              <a:schemeClr val="bg1"/>
-            </a:solidFill>
-            <a:ln>
-              <a:solidFill>
-                <a:schemeClr val="bg1"/>
-              </a:solidFill>
-            </a:ln>
-          </p:spPr>
-          <p:style>
-            <a:lnRef idx="2">
-              <a:schemeClr val="accent1">
-                <a:lumMod val="75000"/>
-              </a:schemeClr>
-            </a:lnRef>
-            <a:fillRef idx="1">
-              <a:schemeClr val="accent1"/>
-            </a:fillRef>
-            <a:effectRef idx="0">
-              <a:srgbClr val="FFFFFF"/>
-            </a:effectRef>
-            <a:fontRef idx="minor">
-              <a:schemeClr val="lt1"/>
-            </a:fontRef>
-          </p:style>
-          <p:txBody>
-            <a:bodyPr rtlCol="0" anchor="ctr"/>
-            <a:p>
-              <a:pPr algn="ctr"/>
-              <a:endParaRPr lang="zh-CN" altLang="en-US"/>
-            </a:p>
-          </p:txBody>
-        </p:sp>
-        <p:sp>
-          <p:nvSpPr>
-            <p:cNvPr id="7" name="矩形 6"/>
-            <p:cNvSpPr/>
-            <p:nvPr/>
-          </p:nvSpPr>
-          <p:spPr>
-            <a:xfrm>
-              <a:off x="1607" y="5736"/>
-              <a:ext cx="232" cy="224"/>
-            </a:xfrm>
-            <a:prstGeom prst="rect">
-              <a:avLst/>
-            </a:prstGeom>
-            <a:solidFill>
-              <a:schemeClr val="bg1"/>
-            </a:solidFill>
-            <a:ln>
-              <a:solidFill>
-                <a:schemeClr val="bg1"/>
-              </a:solidFill>
-            </a:ln>
-          </p:spPr>
-          <p:style>
-            <a:lnRef idx="2">
-              <a:schemeClr val="accent1">
-                <a:lumMod val="75000"/>
-              </a:schemeClr>
-            </a:lnRef>
-            <a:fillRef idx="1">
-              <a:schemeClr val="accent1"/>
-            </a:fillRef>
-            <a:effectRef idx="0">
-              <a:srgbClr val="FFFFFF"/>
-            </a:effectRef>
-            <a:fontRef idx="minor">
-              <a:schemeClr val="lt1"/>
-            </a:fontRef>
-          </p:style>
-          <p:txBody>
-            <a:bodyPr rtlCol="0" anchor="ctr"/>
-            <a:p>
-              <a:pPr algn="ctr"/>
-              <a:endParaRPr lang="zh-CN" altLang="en-US"/>
-            </a:p>
-          </p:txBody>
-        </p:sp>
-        <p:sp>
-          <p:nvSpPr>
-            <p:cNvPr id="8" name="矩形 7"/>
-            <p:cNvSpPr/>
-            <p:nvPr/>
-          </p:nvSpPr>
-          <p:spPr>
-            <a:xfrm>
-              <a:off x="8832" y="5736"/>
-              <a:ext cx="232" cy="224"/>
-            </a:xfrm>
-            <a:prstGeom prst="rect">
-              <a:avLst/>
-            </a:prstGeom>
-            <a:solidFill>
-              <a:schemeClr val="bg1"/>
-            </a:solidFill>
-            <a:ln>
-              <a:solidFill>
-                <a:schemeClr val="bg1"/>
-              </a:solidFill>
-            </a:ln>
-          </p:spPr>
-          <p:style>
-            <a:lnRef idx="2">
-              <a:schemeClr val="accent1">
-                <a:lumMod val="75000"/>
-              </a:schemeClr>
-            </a:lnRef>
-            <a:fillRef idx="1">
-              <a:schemeClr val="accent1"/>
-            </a:fillRef>
-            <a:effectRef idx="0">
-              <a:srgbClr val="FFFFFF"/>
-            </a:effectRef>
-            <a:fontRef idx="minor">
-              <a:schemeClr val="lt1"/>
-            </a:fontRef>
-          </p:style>
-          <p:txBody>
-            <a:bodyPr rtlCol="0" anchor="ctr"/>
-            <a:p>
-              <a:pPr algn="ctr"/>
-              <a:endParaRPr lang="zh-CN" altLang="en-US"/>
-            </a:p>
-          </p:txBody>
-        </p:sp>
-      </p:grpSp>
+          </a:xfrm>
+          <a:prstGeom prst="rect">
+            <a:avLst/>
+          </a:prstGeom>
+        </p:spPr>
+      </p:pic>
       <p:sp>
         <p:nvSpPr>
           <p:cNvPr id="17" name="文本框 16"/>
@@ -6785,14 +5852,13 @@
           <a:noFill/>
         </p:spPr>
         <p:txBody>
-          <a:bodyPr wrap="square" rtlCol="0">
+          <a:bodyPr wrap="none" rtlCol="0">
             <a:noAutofit/>
           </a:bodyPr>
           <a:p>
             <a:r>
-              <a:rPr lang="en-US" altLang="zh-CN" sz="1600" b="1">
-                <a:latin typeface="Arial" panose="020B0604020202020204" pitchFamily="34" charset="0"/>
-                <a:cs typeface="Arial" panose="020B0604020202020204" pitchFamily="34" charset="0"/>
+              <a:rPr b="1" sz="1600">
+                <a:latin typeface="Arial"/>
               </a:rPr>
               <a:t>(a)</a:t>
             </a:r>
@@ -6820,14 +5886,13 @@
           <a:noFill/>
         </p:spPr>
         <p:txBody>
-          <a:bodyPr wrap="square" rtlCol="0">
+          <a:bodyPr wrap="none" rtlCol="0">
             <a:noAutofit/>
           </a:bodyPr>
           <a:p>
             <a:r>
-              <a:rPr lang="en-US" altLang="zh-CN" sz="1600" b="1">
-                <a:latin typeface="Arial" panose="020B0604020202020204" pitchFamily="34" charset="0"/>
-                <a:cs typeface="Arial" panose="020B0604020202020204" pitchFamily="34" charset="0"/>
+              <a:rPr b="1" sz="1600">
+                <a:latin typeface="Arial"/>
               </a:rPr>
               <a:t>(b)</a:t>
             </a:r>
@@ -6855,14 +5920,13 @@
           <a:noFill/>
         </p:spPr>
         <p:txBody>
-          <a:bodyPr wrap="square" rtlCol="0">
+          <a:bodyPr wrap="none" rtlCol="0">
             <a:noAutofit/>
           </a:bodyPr>
           <a:p>
             <a:r>
-              <a:rPr lang="en-US" altLang="zh-CN" sz="1600" b="1">
-                <a:latin typeface="Arial" panose="020B0604020202020204" pitchFamily="34" charset="0"/>
-                <a:cs typeface="Arial" panose="020B0604020202020204" pitchFamily="34" charset="0"/>
+              <a:rPr b="1" sz="1600">
+                <a:latin typeface="Arial"/>
               </a:rPr>
               <a:t>(c)</a:t>
             </a:r>
@@ -6890,14 +5954,13 @@
           <a:noFill/>
         </p:spPr>
         <p:txBody>
-          <a:bodyPr wrap="square" rtlCol="0">
+          <a:bodyPr wrap="none" rtlCol="0">
             <a:noAutofit/>
           </a:bodyPr>
           <a:p>
             <a:r>
-              <a:rPr lang="en-US" altLang="zh-CN" sz="1600" b="1">
-                <a:latin typeface="Arial" panose="020B0604020202020204" pitchFamily="34" charset="0"/>
-                <a:cs typeface="Arial" panose="020B0604020202020204" pitchFamily="34" charset="0"/>
+              <a:rPr b="1" sz="1600">
+                <a:latin typeface="Arial"/>
               </a:rPr>
               <a:t>(d)</a:t>
             </a:r>
@@ -6917,7 +5980,7 @@
 </file>
 
 <file path=ppt/slides/slide8.xml><?xml version="1.0" encoding="utf-8"?>
-<p:sld xmlns:a="http://schemas.openxmlformats.org/drawingml/2006/main" xmlns:p="http://schemas.openxmlformats.org/presentationml/2006/main" xmlns:r="http://schemas.openxmlformats.org/officeDocument/2006/relationships">
+<p:sld xmlns:a="http://schemas.openxmlformats.org/drawingml/2006/main" xmlns:r="http://schemas.openxmlformats.org/officeDocument/2006/relationships" xmlns:p="http://schemas.openxmlformats.org/presentationml/2006/main">
   <p:cSld>
     <p:spTree>
       <p:nvGrpSpPr>
@@ -6972,14 +6035,14 @@
       </p:sp>
       <p:pic>
         <p:nvPicPr>
-          <p:cNvPr id="3" name="Picture 2" descr="ch05_09_a.png"/>
+          <p:cNvPr id="3" name="Picture 2" descr="Chapter05_local_08.png"/>
           <p:cNvPicPr>
             <a:picLocks noChangeAspect="1"/>
           </p:cNvPicPr>
           <p:nvPr/>
         </p:nvPicPr>
         <p:blipFill>
-          <a:blip r:embed="rId2"/>
+          <a:blip r:embed="rId1"/>
           <a:stretch>
             <a:fillRect/>
           </a:stretch>
@@ -6987,160 +6050,13 @@
         <p:spPr>
           <a:xfrm>
             <a:off x="228600" y="502920"/>
-            <a:ext cx="2810256" cy="2893454"/>
+            <a:ext cx="8686800" cy="4540827"/>
           </a:xfrm>
           <a:prstGeom prst="rect">
             <a:avLst/>
           </a:prstGeom>
         </p:spPr>
       </p:pic>
-      <p:sp>
-        <p:nvSpPr>
-          <p:cNvPr id="4" name="TextBox 3"/>
-          <p:cNvSpPr txBox="1"/>
-          <p:nvPr/>
-        </p:nvSpPr>
-        <p:spPr>
-          <a:xfrm>
-            <a:off x="274320" y="521208"/>
-            <a:ext cx="548640" cy="274320"/>
-          </a:xfrm>
-          <a:prstGeom prst="rect">
-            <a:avLst/>
-          </a:prstGeom>
-          <a:noFill/>
-        </p:spPr>
-        <p:txBody>
-          <a:bodyPr wrap="none" lIns="0" rIns="0" tIns="0" bIns="0">
-            <a:spAutoFit/>
-          </a:bodyPr>
-          <a:lstStyle/>
-          <a:p>
-            <a:r>
-              <a:rPr b="1" sz="1400">
-                <a:solidFill>
-                  <a:srgbClr val="202020"/>
-                </a:solidFill>
-              </a:rPr>
-              <a:t>(a)</a:t>
-            </a:r>
-          </a:p>
-        </p:txBody>
-      </p:sp>
-      <p:pic>
-        <p:nvPicPr>
-          <p:cNvPr id="5" name="Picture 4" descr="ch05_09_b.png"/>
-          <p:cNvPicPr>
-            <a:picLocks noChangeAspect="1"/>
-          </p:cNvPicPr>
-          <p:nvPr/>
-        </p:nvPicPr>
-        <p:blipFill>
-          <a:blip r:embed="rId3"/>
-          <a:stretch>
-            <a:fillRect/>
-          </a:stretch>
-        </p:blipFill>
-        <p:spPr>
-          <a:xfrm>
-            <a:off x="3166872" y="502920"/>
-            <a:ext cx="2810256" cy="2353716"/>
-          </a:xfrm>
-          <a:prstGeom prst="rect">
-            <a:avLst/>
-          </a:prstGeom>
-        </p:spPr>
-      </p:pic>
-      <p:sp>
-        <p:nvSpPr>
-          <p:cNvPr id="6" name="TextBox 5"/>
-          <p:cNvSpPr txBox="1"/>
-          <p:nvPr/>
-        </p:nvSpPr>
-        <p:spPr>
-          <a:xfrm>
-            <a:off x="3212592" y="521208"/>
-            <a:ext cx="548640" cy="274320"/>
-          </a:xfrm>
-          <a:prstGeom prst="rect">
-            <a:avLst/>
-          </a:prstGeom>
-          <a:noFill/>
-        </p:spPr>
-        <p:txBody>
-          <a:bodyPr wrap="none" lIns="0" rIns="0" tIns="0" bIns="0">
-            <a:spAutoFit/>
-          </a:bodyPr>
-          <a:lstStyle/>
-          <a:p>
-            <a:r>
-              <a:rPr b="1" sz="1400">
-                <a:solidFill>
-                  <a:srgbClr val="202020"/>
-                </a:solidFill>
-              </a:rPr>
-              <a:t>(b)</a:t>
-            </a:r>
-          </a:p>
-        </p:txBody>
-      </p:sp>
-      <p:pic>
-        <p:nvPicPr>
-          <p:cNvPr id="7" name="Picture 6" descr="ch05_09_c.png"/>
-          <p:cNvPicPr>
-            <a:picLocks noChangeAspect="1"/>
-          </p:cNvPicPr>
-          <p:nvPr/>
-        </p:nvPicPr>
-        <p:blipFill>
-          <a:blip r:embed="rId4"/>
-          <a:stretch>
-            <a:fillRect/>
-          </a:stretch>
-        </p:blipFill>
-        <p:spPr>
-          <a:xfrm>
-            <a:off x="6105144" y="502920"/>
-            <a:ext cx="2810256" cy="2221130"/>
-          </a:xfrm>
-          <a:prstGeom prst="rect">
-            <a:avLst/>
-          </a:prstGeom>
-        </p:spPr>
-      </p:pic>
-      <p:sp>
-        <p:nvSpPr>
-          <p:cNvPr id="8" name="TextBox 7"/>
-          <p:cNvSpPr txBox="1"/>
-          <p:nvPr/>
-        </p:nvSpPr>
-        <p:spPr>
-          <a:xfrm>
-            <a:off x="6150864" y="521208"/>
-            <a:ext cx="548640" cy="274320"/>
-          </a:xfrm>
-          <a:prstGeom prst="rect">
-            <a:avLst/>
-          </a:prstGeom>
-          <a:noFill/>
-        </p:spPr>
-        <p:txBody>
-          <a:bodyPr wrap="none" lIns="0" rIns="0" tIns="0" bIns="0">
-            <a:spAutoFit/>
-          </a:bodyPr>
-          <a:lstStyle/>
-          <a:p>
-            <a:r>
-              <a:rPr b="1" sz="1400">
-                <a:solidFill>
-                  <a:srgbClr val="202020"/>
-                </a:solidFill>
-              </a:rPr>
-              <a:t>(c)</a:t>
-            </a:r>
-          </a:p>
-        </p:txBody>
-      </p:sp>
     </p:spTree>
   </p:cSld>
   <p:clrMapOvr>
@@ -7150,7 +6066,7 @@
 </file>
 
 <file path=ppt/slides/slide9.xml><?xml version="1.0" encoding="utf-8"?>
-<p:sld xmlns:a="http://schemas.openxmlformats.org/drawingml/2006/main" xmlns:p="http://schemas.openxmlformats.org/presentationml/2006/main" xmlns:r="http://schemas.openxmlformats.org/officeDocument/2006/relationships">
+<p:sld xmlns:a="http://schemas.openxmlformats.org/drawingml/2006/main" xmlns:r="http://schemas.openxmlformats.org/officeDocument/2006/relationships" xmlns:p="http://schemas.openxmlformats.org/presentationml/2006/main">
   <p:cSld>
     <p:spTree>
       <p:nvGrpSpPr>
@@ -7205,14 +6121,14 @@
       </p:sp>
       <p:pic>
         <p:nvPicPr>
-          <p:cNvPr id="3" name="Picture 2" descr="Chapter05_local_08.png"/>
+          <p:cNvPr id="3" name="Picture 2" descr="ch05_09_a.png"/>
           <p:cNvPicPr>
             <a:picLocks noChangeAspect="1"/>
           </p:cNvPicPr>
           <p:nvPr/>
         </p:nvPicPr>
         <p:blipFill>
-          <a:blip r:embed="rId2"/>
+          <a:blip r:embed="rId6"/>
           <a:stretch>
             <a:fillRect/>
           </a:stretch>
@@ -7220,13 +6136,160 @@
         <p:spPr>
           <a:xfrm>
             <a:off x="228600" y="502920"/>
-            <a:ext cx="8686800" cy="4540827"/>
+            <a:ext cx="2810256" cy="2899814"/>
           </a:xfrm>
           <a:prstGeom prst="rect">
             <a:avLst/>
           </a:prstGeom>
         </p:spPr>
       </p:pic>
+      <p:sp>
+        <p:nvSpPr>
+          <p:cNvPr id="4" name="TextBox 3"/>
+          <p:cNvSpPr txBox="1"/>
+          <p:nvPr/>
+        </p:nvSpPr>
+        <p:spPr>
+          <a:xfrm>
+            <a:off x="274320" y="521208"/>
+            <a:ext cx="548640" cy="274320"/>
+          </a:xfrm>
+          <a:prstGeom prst="rect">
+            <a:avLst/>
+          </a:prstGeom>
+          <a:noFill/>
+        </p:spPr>
+        <p:txBody>
+          <a:bodyPr wrap="none" lIns="0" rIns="0" tIns="0" bIns="0">
+            <a:spAutoFit/>
+          </a:bodyPr>
+          <a:lstStyle/>
+          <a:p>
+            <a:r>
+              <a:rPr b="1" sz="1400">
+                <a:solidFill>
+                  <a:srgbClr val="202020"/>
+                </a:solidFill>
+              </a:rPr>
+              <a:t>(a)</a:t>
+            </a:r>
+          </a:p>
+        </p:txBody>
+      </p:sp>
+      <p:pic>
+        <p:nvPicPr>
+          <p:cNvPr id="5" name="Picture 4" descr="ch05_09_b.png"/>
+          <p:cNvPicPr>
+            <a:picLocks noChangeAspect="1"/>
+          </p:cNvPicPr>
+          <p:nvPr/>
+        </p:nvPicPr>
+        <p:blipFill>
+          <a:blip r:embed="rId7"/>
+          <a:stretch>
+            <a:fillRect/>
+          </a:stretch>
+        </p:blipFill>
+        <p:spPr>
+          <a:xfrm>
+            <a:off x="3166872" y="502920"/>
+            <a:ext cx="2810256" cy="2364386"/>
+          </a:xfrm>
+          <a:prstGeom prst="rect">
+            <a:avLst/>
+          </a:prstGeom>
+        </p:spPr>
+      </p:pic>
+      <p:sp>
+        <p:nvSpPr>
+          <p:cNvPr id="6" name="TextBox 5"/>
+          <p:cNvSpPr txBox="1"/>
+          <p:nvPr/>
+        </p:nvSpPr>
+        <p:spPr>
+          <a:xfrm>
+            <a:off x="3212592" y="521208"/>
+            <a:ext cx="548640" cy="274320"/>
+          </a:xfrm>
+          <a:prstGeom prst="rect">
+            <a:avLst/>
+          </a:prstGeom>
+          <a:noFill/>
+        </p:spPr>
+        <p:txBody>
+          <a:bodyPr wrap="none" lIns="0" rIns="0" tIns="0" bIns="0">
+            <a:spAutoFit/>
+          </a:bodyPr>
+          <a:lstStyle/>
+          <a:p>
+            <a:r>
+              <a:rPr b="1" sz="1400">
+                <a:solidFill>
+                  <a:srgbClr val="202020"/>
+                </a:solidFill>
+              </a:rPr>
+              <a:t>(b)</a:t>
+            </a:r>
+          </a:p>
+        </p:txBody>
+      </p:sp>
+      <p:pic>
+        <p:nvPicPr>
+          <p:cNvPr id="7" name="Picture 6" descr="ch05_09_c.png"/>
+          <p:cNvPicPr>
+            <a:picLocks noChangeAspect="1"/>
+          </p:cNvPicPr>
+          <p:nvPr/>
+        </p:nvPicPr>
+        <p:blipFill>
+          <a:blip r:embed="rId8"/>
+          <a:stretch>
+            <a:fillRect/>
+          </a:stretch>
+        </p:blipFill>
+        <p:spPr>
+          <a:xfrm>
+            <a:off x="6105144" y="502920"/>
+            <a:ext cx="2810256" cy="2369065"/>
+          </a:xfrm>
+          <a:prstGeom prst="rect">
+            <a:avLst/>
+          </a:prstGeom>
+        </p:spPr>
+      </p:pic>
+      <p:sp>
+        <p:nvSpPr>
+          <p:cNvPr id="8" name="TextBox 7"/>
+          <p:cNvSpPr txBox="1"/>
+          <p:nvPr/>
+        </p:nvSpPr>
+        <p:spPr>
+          <a:xfrm>
+            <a:off x="6150864" y="521208"/>
+            <a:ext cx="548640" cy="274320"/>
+          </a:xfrm>
+          <a:prstGeom prst="rect">
+            <a:avLst/>
+          </a:prstGeom>
+          <a:noFill/>
+        </p:spPr>
+        <p:txBody>
+          <a:bodyPr wrap="none" lIns="0" rIns="0" tIns="0" bIns="0">
+            <a:spAutoFit/>
+          </a:bodyPr>
+          <a:lstStyle/>
+          <a:p>
+            <a:r>
+              <a:rPr b="1" sz="1400">
+                <a:solidFill>
+                  <a:srgbClr val="202020"/>
+                </a:solidFill>
+              </a:rPr>
+              <a:t>(c)</a:t>
+            </a:r>
+          </a:p>
+        </p:txBody>
+      </p:sp>
     </p:spTree>
   </p:cSld>
   <p:clrMapOvr>

</xml_diff>

<commit_message>
R3+R4: IR column-height boundary + thermal-clock axis sync
- R3 (nodal_ir_scaling.py, exact solver anchored to ngspice at N=64): uncompensated threshold absorption holds to N<=32 (slope>=0.90, lossless decisions); N=64 sits just outside (0.69 slope, 95.5% vs ideal comparator); N>=128 unrecoverable by one-point recalibration - section 4.3's 256x256 claim replaced by the measured boundary with a cross-reference, section 4.6 gains the quantitative rule + ir_nscan footnote (caliber distinction vs the 86% replay figure)
- R4: exp19 switched to the calibrated thermal chain - tau endpoints 370/7 ns, uncompensated MC drift 5.37 (was 2.33 on the simplified axis), compensated residual 0.32; caption/prose/footnote synced to as-built tense, fig 5.4 refreshed through the deck
- both docx regenerated; tests green

Co-Authored-By: Claude Fable 5 <noreply@anthropic.com>
</commit_message>
<xml_diff>
--- a/article/ppt/Chapter05_local.pptx
+++ b/article/ppt/Chapter05_local.pptx
@@ -4341,7 +4341,7 @@
       </p:sp>
       <p:pic>
         <p:nvPicPr>
-          <p:cNvPr id="3" name="Picture 2" descr="31_rc_counting_readout.png"/>
+          <p:cNvPr id="3" name="Picture 2" descr="image.png"/>
           <p:cNvPicPr>
             <a:picLocks noChangeAspect="1"/>
           </p:cNvPicPr>
@@ -5202,7 +5202,7 @@
           <p:spPr>
             <a:xfrm>
               <a:off x="0" y="1040"/>
-              <a:ext cx="14400" cy="9517"/>
+              <a:ext cx="14400" cy="10315"/>
             </a:xfrm>
             <a:prstGeom prst="rect">
               <a:avLst/>

</xml_diff>